<commit_message>
docs(presentation): update slides with dual conflict protection (room & participant advisory)
</commit_message>
<xml_diff>
--- a/MeetThink_Presentation.pptx
+++ b/MeetThink_Presentation.pptx
@@ -4,9 +4,6 @@
   <p:sldMasterIdLst>
     <p:sldMasterId id="2147483648" r:id="rId1"/>
   </p:sldMasterIdLst>
-  <p:notesMasterIdLst>
-    <p:notesMasterId r:id="rId13"/>
-  </p:notesMasterIdLst>
   <p:sldIdLst>
     <p:sldId id="256" r:id="rId2"/>
     <p:sldId id="257" r:id="rId3"/>
@@ -20,8 +17,11 @@
     <p:sldId id="265" r:id="rId11"/>
     <p:sldId id="266" r:id="rId12"/>
   </p:sldIdLst>
-  <p:sldSz cx="12192000" cy="6858000"/>
-  <p:notesSz cx="6858000" cy="12192000"/>
+  <p:notesMasterIdLst>
+    <p:notesMasterId r:id="rId13"/>
+  </p:notesMasterIdLst>
+  <p:sldSz cx="12191695" cy="6858000"/>
+  <p:notesSz cx="6858000" cy="12191695"/>
   <p:defaultTextStyle>
     <a:lvl1pPr marL="0" algn="l" defTabSz="914400" rtl="0" eaLnBrk="1" latinLnBrk="0" hangingPunct="1">
       <a:defRPr sz="1800" kern="1200">
@@ -114,11 +114,6 @@
       </a:defRPr>
     </a:lvl9pPr>
   </p:defaultTextStyle>
-  <p:extLst>
-    <p:ext uri="{EFAFB233-063F-42B5-8137-9DF3F51BA10A}">
-      <p15:sldGuideLst xmlns:p15="http://schemas.microsoft.com/office/powerpoint/2012/main"/>
-    </p:ext>
-  </p:extLst>
 </p:presentation>
 </file>
 
@@ -144,10 +139,234 @@
           <a:chExt cx="0" cy="0"/>
         </a:xfrm>
       </p:grpSpPr>
+      <p:sp>
+        <p:nvSpPr>
+          <p:cNvPr id="2" name="Header Placeholder 1"/>
+          <p:cNvSpPr>
+            <a:spLocks noGrp="1"/>
+          </p:cNvSpPr>
+          <p:nvPr>
+            <p:ph type="hdr" sz="quarter"/>
+          </p:nvPr>
+        </p:nvSpPr>
+        <p:spPr>
+          <a:xfrm>
+            <a:off x="0" y="0"/>
+            <a:ext cx="2971800" cy="458788"/>
+          </a:xfrm>
+          <a:prstGeom prst="rect">
+            <a:avLst/>
+          </a:prstGeom>
+        </p:spPr>
+        <p:txBody>
+          <a:bodyPr vert="horz" lIns="91440" tIns="45720" rIns="91440" bIns="45720" rtlCol="0"/>
+          <a:lstStyle>
+            <a:lvl1pPr algn="l">
+              <a:defRPr sz="1200"/>
+            </a:lvl1pPr>
+          </a:lstStyle>
+          <a:p>
+            <a:endParaRPr lang="en-US"/>
+          </a:p>
+        </p:txBody>
+      </p:sp>
+      <p:sp>
+        <p:nvSpPr>
+          <p:cNvPr id="3" name="Date Placeholder 2"/>
+          <p:cNvSpPr>
+            <a:spLocks noGrp="1"/>
+          </p:cNvSpPr>
+          <p:nvPr>
+            <p:ph type="dt" idx="1"/>
+          </p:nvPr>
+        </p:nvSpPr>
+        <p:spPr>
+          <a:xfrm>
+            <a:off x="3884613" y="0"/>
+            <a:ext cx="2971800" cy="458788"/>
+          </a:xfrm>
+          <a:prstGeom prst="rect">
+            <a:avLst/>
+          </a:prstGeom>
+        </p:spPr>
+        <p:txBody>
+          <a:bodyPr vert="horz" lIns="91440" tIns="45720" rIns="91440" bIns="45720" rtlCol="0"/>
+          <a:lstStyle>
+            <a:lvl1pPr algn="r">
+              <a:defRPr sz="1200"/>
+            </a:lvl1pPr>
+          </a:lstStyle>
+          <a:p>
+            <a:fld id="{5282F153-3F37-0F45-9E97-73ACFA13230C}" type="datetimeFigureOut">
+              <a:rPr lang="en-US"/>
+              <a:t>7/23/19</a:t>
+            </a:fld>
+            <a:endParaRPr lang="en-US"/>
+          </a:p>
+        </p:txBody>
+      </p:sp>
+      <p:sp>
+        <p:nvSpPr>
+          <p:cNvPr id="4" name="Slide Image Placeholder 3"/>
+          <p:cNvSpPr>
+            <a:spLocks noGrp="1" noRot="1" noChangeAspect="1"/>
+          </p:cNvSpPr>
+          <p:nvPr>
+            <p:ph type="sldImg" idx="2"/>
+          </p:nvPr>
+        </p:nvSpPr>
+        <p:spPr>
+          <a:xfrm>
+            <a:off x="685800" y="1143000"/>
+            <a:ext cx="5486400" cy="3086100"/>
+          </a:xfrm>
+          <a:prstGeom prst="rect">
+            <a:avLst/>
+          </a:prstGeom>
+          <a:noFill/>
+          <a:ln w="12700">
+            <a:solidFill>
+              <a:prstClr val="black"/>
+            </a:solidFill>
+          </a:ln>
+        </p:spPr>
+        <p:txBody>
+          <a:bodyPr vert="horz" lIns="91440" tIns="45720" rIns="91440" bIns="45720" rtlCol="0" anchor="ctr"/>
+          <a:lstStyle/>
+          <a:p>
+            <a:endParaRPr lang="en-US"/>
+          </a:p>
+        </p:txBody>
+      </p:sp>
+      <p:sp>
+        <p:nvSpPr>
+          <p:cNvPr id="5" name="Notes Placeholder 4"/>
+          <p:cNvSpPr>
+            <a:spLocks noGrp="1"/>
+          </p:cNvSpPr>
+          <p:nvPr>
+            <p:ph type="body" sz="quarter" idx="3"/>
+          </p:nvPr>
+        </p:nvSpPr>
+        <p:spPr>
+          <a:xfrm>
+            <a:off x="685800" y="4400550"/>
+            <a:ext cx="5486400" cy="3600450"/>
+          </a:xfrm>
+          <a:prstGeom prst="rect">
+            <a:avLst/>
+          </a:prstGeom>
+        </p:spPr>
+        <p:txBody>
+          <a:bodyPr vert="horz" lIns="91440" tIns="45720" rIns="91440" bIns="45720" rtlCol="0"/>
+          <a:lstStyle/>
+          <a:p>
+            <a:pPr lvl="0"/>
+            <a:r>
+              <a:rPr lang="en-US"/>
+              <a:t>Click to edit Master text styles</a:t>
+            </a:r>
+          </a:p>
+          <a:p>
+            <a:pPr lvl="1"/>
+            <a:r>
+              <a:rPr lang="en-US"/>
+              <a:t>Second level</a:t>
+            </a:r>
+          </a:p>
+          <a:p>
+            <a:pPr lvl="2"/>
+            <a:r>
+              <a:rPr lang="en-US"/>
+              <a:t>Third level</a:t>
+            </a:r>
+          </a:p>
+          <a:p>
+            <a:pPr lvl="3"/>
+            <a:r>
+              <a:rPr lang="en-US"/>
+              <a:t>Fourth level</a:t>
+            </a:r>
+          </a:p>
+          <a:p>
+            <a:pPr lvl="4"/>
+            <a:r>
+              <a:rPr lang="en-US"/>
+              <a:t>Fifth level</a:t>
+            </a:r>
+          </a:p>
+        </p:txBody>
+      </p:sp>
+      <p:sp>
+        <p:nvSpPr>
+          <p:cNvPr id="6" name="Footer Placeholder 5"/>
+          <p:cNvSpPr>
+            <a:spLocks noGrp="1"/>
+          </p:cNvSpPr>
+          <p:nvPr>
+            <p:ph type="ftr" sz="quarter" idx="4"/>
+          </p:nvPr>
+        </p:nvSpPr>
+        <p:spPr>
+          <a:xfrm>
+            <a:off x="0" y="8685213"/>
+            <a:ext cx="2971800" cy="458787"/>
+          </a:xfrm>
+          <a:prstGeom prst="rect">
+            <a:avLst/>
+          </a:prstGeom>
+        </p:spPr>
+        <p:txBody>
+          <a:bodyPr vert="horz" lIns="91440" tIns="45720" rIns="91440" bIns="45720" rtlCol="0" anchor="b"/>
+          <a:lstStyle>
+            <a:lvl1pPr algn="l">
+              <a:defRPr sz="1200"/>
+            </a:lvl1pPr>
+          </a:lstStyle>
+          <a:p>
+            <a:endParaRPr lang="en-US"/>
+          </a:p>
+        </p:txBody>
+      </p:sp>
+      <p:sp>
+        <p:nvSpPr>
+          <p:cNvPr id="7" name="Slide Number Placeholder 6"/>
+          <p:cNvSpPr>
+            <a:spLocks noGrp="1"/>
+          </p:cNvSpPr>
+          <p:nvPr>
+            <p:ph type="sldNum" sz="quarter" idx="5"/>
+          </p:nvPr>
+        </p:nvSpPr>
+        <p:spPr>
+          <a:xfrm>
+            <a:off x="3884613" y="8685213"/>
+            <a:ext cx="2971800" cy="458787"/>
+          </a:xfrm>
+          <a:prstGeom prst="rect">
+            <a:avLst/>
+          </a:prstGeom>
+        </p:spPr>
+        <p:txBody>
+          <a:bodyPr vert="horz" lIns="91440" tIns="45720" rIns="91440" bIns="45720" rtlCol="0" anchor="b"/>
+          <a:lstStyle>
+            <a:lvl1pPr algn="r">
+              <a:defRPr sz="1200"/>
+            </a:lvl1pPr>
+          </a:lstStyle>
+          <a:p>
+            <a:fld id="{CE5E9CC1-C706-0F49-92D6-E571CC5EEA8F}" type="slidenum">
+              <a:rPr lang="en-US"/>
+              <a:t>‹#›</a:t>
+            </a:fld>
+            <a:endParaRPr lang="en-US"/>
+          </a:p>
+        </p:txBody>
+      </p:sp>
     </p:spTree>
     <p:extLst>
       <p:ext uri="{BB962C8B-B14F-4D97-AF65-F5344CB8AC3E}">
-        <p14:creationId xmlns:p14="http://schemas.microsoft.com/office/powerpoint/2010/main" val="4146447355"/>
+        <p14:creationId xmlns:p14="http://schemas.microsoft.com/office/powerpoint/2010/main" val="1024086991"/>
       </p:ext>
     </p:extLst>
   </p:cSld>
@@ -291,6 +510,10 @@
           <a:bodyPr/>
           <a:lstStyle/>
           <a:p>
+            <a:r>
+              <a:rPr lang="en-US" dirty="0"/>
+              <a:t/>
+            </a:r>
             <a:endParaRPr lang="en-US" dirty="0"/>
           </a:p>
         </p:txBody>
@@ -375,6 +598,10 @@
           <a:bodyPr/>
           <a:lstStyle/>
           <a:p>
+            <a:r>
+              <a:rPr lang="en-US" dirty="0"/>
+              <a:t/>
+            </a:r>
             <a:endParaRPr lang="en-US" dirty="0"/>
           </a:p>
         </p:txBody>
@@ -459,6 +686,10 @@
           <a:bodyPr/>
           <a:lstStyle/>
           <a:p>
+            <a:r>
+              <a:rPr lang="en-US" dirty="0"/>
+              <a:t/>
+            </a:r>
             <a:endParaRPr lang="en-US" dirty="0"/>
           </a:p>
         </p:txBody>
@@ -543,6 +774,10 @@
           <a:bodyPr/>
           <a:lstStyle/>
           <a:p>
+            <a:r>
+              <a:rPr lang="en-US" dirty="0"/>
+              <a:t/>
+            </a:r>
             <a:endParaRPr lang="en-US" dirty="0"/>
           </a:p>
         </p:txBody>
@@ -627,6 +862,10 @@
           <a:bodyPr/>
           <a:lstStyle/>
           <a:p>
+            <a:r>
+              <a:rPr lang="en-US" dirty="0"/>
+              <a:t/>
+            </a:r>
             <a:endParaRPr lang="en-US" dirty="0"/>
           </a:p>
         </p:txBody>
@@ -711,6 +950,10 @@
           <a:bodyPr/>
           <a:lstStyle/>
           <a:p>
+            <a:r>
+              <a:rPr lang="en-US" dirty="0"/>
+              <a:t/>
+            </a:r>
             <a:endParaRPr lang="en-US" dirty="0"/>
           </a:p>
         </p:txBody>
@@ -795,6 +1038,10 @@
           <a:bodyPr/>
           <a:lstStyle/>
           <a:p>
+            <a:r>
+              <a:rPr lang="en-US" dirty="0"/>
+              <a:t/>
+            </a:r>
             <a:endParaRPr lang="en-US" dirty="0"/>
           </a:p>
         </p:txBody>
@@ -879,6 +1126,10 @@
           <a:bodyPr/>
           <a:lstStyle/>
           <a:p>
+            <a:r>
+              <a:rPr lang="en-US" dirty="0"/>
+              <a:t/>
+            </a:r>
             <a:endParaRPr lang="en-US" dirty="0"/>
           </a:p>
         </p:txBody>
@@ -963,6 +1214,10 @@
           <a:bodyPr/>
           <a:lstStyle/>
           <a:p>
+            <a:r>
+              <a:rPr lang="en-US" dirty="0"/>
+              <a:t/>
+            </a:r>
             <a:endParaRPr lang="en-US" dirty="0"/>
           </a:p>
         </p:txBody>
@@ -1047,6 +1302,10 @@
           <a:bodyPr/>
           <a:lstStyle/>
           <a:p>
+            <a:r>
+              <a:rPr lang="en-US" dirty="0"/>
+              <a:t/>
+            </a:r>
             <a:endParaRPr lang="en-US" dirty="0"/>
           </a:p>
         </p:txBody>
@@ -1131,6 +1390,10 @@
           <a:bodyPr/>
           <a:lstStyle/>
           <a:p>
+            <a:r>
+              <a:rPr lang="en-US" dirty="0"/>
+              <a:t/>
+            </a:r>
             <a:endParaRPr lang="en-US" dirty="0"/>
           </a:p>
         </p:txBody>
@@ -1204,11 +1467,6 @@
 <file path=ppt/slideMasters/slideMaster1.xml><?xml version="1.0" encoding="utf-8"?>
 <p:sldMaster xmlns:a="http://schemas.openxmlformats.org/drawingml/2006/main" xmlns:r="http://schemas.openxmlformats.org/officeDocument/2006/relationships" xmlns:p="http://schemas.openxmlformats.org/presentationml/2006/main">
   <p:cSld>
-    <p:bg>
-      <p:bgRef idx="1001">
-        <a:schemeClr val="bg1"/>
-      </p:bgRef>
-    </p:bg>
     <p:spTree>
       <p:nvGrpSpPr>
         <p:cNvPr id="1" name=""/>
@@ -1491,7 +1749,6 @@
         <a:solidFill>
           <a:srgbClr val="0F172A"/>
         </a:solidFill>
-        <a:effectLst/>
       </p:bgPr>
     </p:bg>
     <p:spTree>
@@ -1576,7 +1833,7 @@
           <a:bodyPr wrap="square" rtlCol="0" anchor="ctr"/>
           <a:lstStyle/>
           <a:p>
-            <a:pPr marL="0" indent="0" algn="ctr">
+            <a:pPr algn="ctr" indent="0" marL="0">
               <a:buNone/>
             </a:pPr>
             <a:r>
@@ -1615,7 +1872,7 @@
           <a:bodyPr wrap="square" rtlCol="0" anchor="ctr"/>
           <a:lstStyle/>
           <a:p>
-            <a:pPr marL="0" indent="0">
+            <a:pPr indent="0" marL="0">
               <a:buNone/>
             </a:pPr>
             <a:r>
@@ -1629,6 +1886,9 @@
               </a:rPr>
               <a:t>Meet</a:t>
             </a:r>
+            <a:pPr indent="0" marL="0">
+              <a:buNone/>
+            </a:pPr>
             <a:r>
               <a:rPr lang="en-US" sz="5200" b="1" dirty="0">
                 <a:solidFill>
@@ -1665,7 +1925,7 @@
           <a:bodyPr wrap="square" rtlCol="0" anchor="ctr"/>
           <a:lstStyle/>
           <a:p>
-            <a:pPr marL="0" indent="0">
+            <a:pPr indent="0" marL="0">
               <a:buNone/>
             </a:pPr>
             <a:r>
@@ -1704,7 +1964,7 @@
           <a:bodyPr wrap="square" rtlCol="0" anchor="ctr"/>
           <a:lstStyle/>
           <a:p>
-            <a:pPr marL="0" indent="0">
+            <a:pPr indent="0" marL="0">
               <a:lnSpc>
                 <a:spcPts val="2000"/>
               </a:lnSpc>
@@ -1724,7 +1984,7 @@
             <a:endParaRPr lang="en-US" sz="1350" dirty="0"/>
           </a:p>
           <a:p>
-            <a:pPr marL="0" indent="0">
+            <a:pPr indent="0" marL="0">
               <a:lnSpc>
                 <a:spcPts val="2000"/>
               </a:lnSpc>
@@ -1793,7 +2053,7 @@
           <a:bodyPr wrap="square" rtlCol="0" anchor="ctr"/>
           <a:lstStyle/>
           <a:p>
-            <a:pPr marL="0" indent="0">
+            <a:pPr indent="0" marL="0">
               <a:buNone/>
             </a:pPr>
             <a:r>
@@ -1832,7 +2092,7 @@
           <a:bodyPr wrap="square" rtlCol="0" anchor="ctr"/>
           <a:lstStyle/>
           <a:p>
-            <a:pPr marL="0" indent="0">
+            <a:pPr indent="0" marL="0">
               <a:buNone/>
             </a:pPr>
             <a:r>
@@ -1898,7 +2158,7 @@
           <a:bodyPr wrap="square" rtlCol="0" anchor="ctr"/>
           <a:lstStyle/>
           <a:p>
-            <a:pPr marL="0" indent="0">
+            <a:pPr indent="0" marL="0">
               <a:buNone/>
             </a:pPr>
             <a:r>
@@ -1937,7 +2197,7 @@
           <a:bodyPr wrap="square" rtlCol="0" anchor="ctr"/>
           <a:lstStyle/>
           <a:p>
-            <a:pPr marL="0" indent="0">
+            <a:pPr indent="0" marL="0">
               <a:buNone/>
             </a:pPr>
             <a:r>
@@ -1955,36 +2215,6 @@
           </a:p>
         </p:txBody>
       </p:sp>
-      <p:pic>
-        <p:nvPicPr>
-          <p:cNvPr id="15" name="Picture 14">
-            <a:extLst>
-              <a:ext uri="{FF2B5EF4-FFF2-40B4-BE49-F238E27FC236}">
-                <a16:creationId xmlns:a16="http://schemas.microsoft.com/office/drawing/2014/main" id="{34C81FBA-0BE6-4197-53DF-60988859B9AA}"/>
-              </a:ext>
-            </a:extLst>
-          </p:cNvPr>
-          <p:cNvPicPr>
-            <a:picLocks noChangeAspect="1"/>
-          </p:cNvPicPr>
-          <p:nvPr/>
-        </p:nvPicPr>
-        <p:blipFill>
-          <a:blip r:embed="rId3"/>
-          <a:stretch>
-            <a:fillRect/>
-          </a:stretch>
-        </p:blipFill>
-        <p:spPr>
-          <a:xfrm>
-            <a:off x="10698480" y="0"/>
-            <a:ext cx="1373393" cy="1373393"/>
-          </a:xfrm>
-          <a:prstGeom prst="rect">
-            <a:avLst/>
-          </a:prstGeom>
-        </p:spPr>
-      </p:pic>
     </p:spTree>
   </p:cSld>
   <p:clrMapOvr>
@@ -2001,7 +2231,6 @@
         <a:solidFill>
           <a:srgbClr val="F8FAFC"/>
         </a:solidFill>
-        <a:effectLst/>
       </p:bgPr>
     </p:bg>
     <p:spTree>
@@ -2066,7 +2295,7 @@
           <a:bodyPr wrap="square" rtlCol="0" anchor="ctr"/>
           <a:lstStyle/>
           <a:p>
-            <a:pPr marL="0" indent="0" algn="ctr">
+            <a:pPr algn="ctr" indent="0" marL="0">
               <a:buNone/>
             </a:pPr>
             <a:r>
@@ -2105,7 +2334,7 @@
           <a:bodyPr wrap="square" rtlCol="0" anchor="t"/>
           <a:lstStyle/>
           <a:p>
-            <a:pPr marL="0" indent="0">
+            <a:pPr indent="0" marL="0">
               <a:buNone/>
             </a:pPr>
             <a:r>
@@ -2164,7 +2393,7 @@
           <a:bodyPr wrap="square" rtlCol="0" anchor="ctr"/>
           <a:lstStyle/>
           <a:p>
-            <a:pPr marL="0" indent="0">
+            <a:pPr indent="0" marL="0">
               <a:buNone/>
             </a:pPr>
             <a:r>
@@ -2230,7 +2459,7 @@
           <a:bodyPr wrap="square" rtlCol="0" anchor="ctr"/>
           <a:lstStyle/>
           <a:p>
-            <a:pPr marL="0" indent="0" algn="ctr">
+            <a:pPr algn="ctr" indent="0" marL="0">
               <a:buNone/>
             </a:pPr>
             <a:r>
@@ -2269,7 +2498,7 @@
           <a:bodyPr wrap="square" rtlCol="0" anchor="ctr"/>
           <a:lstStyle/>
           <a:p>
-            <a:pPr marL="0" indent="0" algn="ctr">
+            <a:pPr algn="ctr" indent="0" marL="0">
               <a:buNone/>
             </a:pPr>
             <a:r>
@@ -2328,7 +2557,7 @@
           <a:bodyPr wrap="square" rtlCol="0" anchor="ctr"/>
           <a:lstStyle/>
           <a:p>
-            <a:pPr marL="0" indent="0" algn="ctr">
+            <a:pPr algn="ctr" indent="0" marL="0">
               <a:lnSpc>
                 <a:spcPts val="1700"/>
               </a:lnSpc>
@@ -2397,7 +2626,7 @@
           <a:bodyPr wrap="square" rtlCol="0" anchor="ctr"/>
           <a:lstStyle/>
           <a:p>
-            <a:pPr marL="0" indent="0" algn="ctr">
+            <a:pPr algn="ctr" indent="0" marL="0">
               <a:buNone/>
             </a:pPr>
             <a:r>
@@ -2436,7 +2665,7 @@
           <a:bodyPr wrap="square" rtlCol="0" anchor="ctr"/>
           <a:lstStyle/>
           <a:p>
-            <a:pPr marL="0" indent="0" algn="ctr">
+            <a:pPr algn="ctr" indent="0" marL="0">
               <a:buNone/>
             </a:pPr>
             <a:r>
@@ -2495,7 +2724,7 @@
           <a:bodyPr wrap="square" rtlCol="0" anchor="ctr"/>
           <a:lstStyle/>
           <a:p>
-            <a:pPr marL="0" indent="0" algn="ctr">
+            <a:pPr algn="ctr" indent="0" marL="0">
               <a:lnSpc>
                 <a:spcPts val="1700"/>
               </a:lnSpc>
@@ -2564,7 +2793,7 @@
           <a:bodyPr wrap="square" rtlCol="0" anchor="ctr"/>
           <a:lstStyle/>
           <a:p>
-            <a:pPr marL="0" indent="0" algn="ctr">
+            <a:pPr algn="ctr" indent="0" marL="0">
               <a:buNone/>
             </a:pPr>
             <a:r>
@@ -2603,7 +2832,7 @@
           <a:bodyPr wrap="square" rtlCol="0" anchor="ctr"/>
           <a:lstStyle/>
           <a:p>
-            <a:pPr marL="0" indent="0" algn="ctr">
+            <a:pPr algn="ctr" indent="0" marL="0">
               <a:buNone/>
             </a:pPr>
             <a:r>
@@ -2662,7 +2891,7 @@
           <a:bodyPr wrap="square" rtlCol="0" anchor="ctr"/>
           <a:lstStyle/>
           <a:p>
-            <a:pPr marL="0" indent="0" algn="ctr">
+            <a:pPr algn="ctr" indent="0" marL="0">
               <a:lnSpc>
                 <a:spcPts val="1700"/>
               </a:lnSpc>
@@ -2731,7 +2960,7 @@
           <a:bodyPr wrap="square" rtlCol="0" anchor="ctr"/>
           <a:lstStyle/>
           <a:p>
-            <a:pPr marL="0" indent="0" algn="ctr">
+            <a:pPr algn="ctr" indent="0" marL="0">
               <a:buNone/>
             </a:pPr>
             <a:r>
@@ -2770,7 +2999,7 @@
           <a:bodyPr wrap="square" rtlCol="0" anchor="ctr"/>
           <a:lstStyle/>
           <a:p>
-            <a:pPr marL="0" indent="0" algn="ctr">
+            <a:pPr algn="ctr" indent="0" marL="0">
               <a:buNone/>
             </a:pPr>
             <a:r>
@@ -2829,7 +3058,7 @@
           <a:bodyPr wrap="square" rtlCol="0" anchor="ctr"/>
           <a:lstStyle/>
           <a:p>
-            <a:pPr marL="0" indent="0" algn="ctr">
+            <a:pPr algn="ctr" indent="0" marL="0">
               <a:lnSpc>
                 <a:spcPts val="1700"/>
               </a:lnSpc>
@@ -2866,7 +3095,6 @@
         <a:solidFill>
           <a:srgbClr val="0F172A"/>
         </a:solidFill>
-        <a:effectLst/>
       </p:bgPr>
     </p:bg>
     <p:spTree>
@@ -2904,7 +3132,7 @@
           <a:bodyPr wrap="square" rtlCol="0" anchor="ctr"/>
           <a:lstStyle/>
           <a:p>
-            <a:pPr marL="0" indent="0" algn="ctr">
+            <a:pPr algn="ctr" indent="0" marL="0">
               <a:buNone/>
             </a:pPr>
             <a:r>
@@ -2943,7 +3171,7 @@
           <a:bodyPr wrap="square" rtlCol="0" anchor="ctr"/>
           <a:lstStyle/>
           <a:p>
-            <a:pPr marL="0" indent="0" algn="ctr">
+            <a:pPr algn="ctr" indent="0" marL="0">
               <a:buNone/>
             </a:pPr>
             <a:r>
@@ -2957,6 +3185,9 @@
               </a:rPr>
               <a:t>Mulai Kolaborasi Rapat Lebih Pintar Bersama </a:t>
             </a:r>
+            <a:pPr algn="ctr" indent="0" marL="0">
+              <a:buNone/>
+            </a:pPr>
             <a:r>
               <a:rPr lang="en-US" sz="2800" b="1" dirty="0">
                 <a:solidFill>
@@ -3020,7 +3251,7 @@
           <a:bodyPr wrap="square" rtlCol="0" anchor="ctr"/>
           <a:lstStyle/>
           <a:p>
-            <a:pPr marL="0" indent="0">
+            <a:pPr indent="0" marL="0">
               <a:buNone/>
             </a:pPr>
             <a:r>
@@ -3059,7 +3290,7 @@
           <a:bodyPr wrap="square" rtlCol="0" anchor="ctr"/>
           <a:lstStyle/>
           <a:p>
-            <a:pPr marL="0" indent="0">
+            <a:pPr indent="0" marL="0">
               <a:lnSpc>
                 <a:spcPts val="1800"/>
               </a:lnSpc>
@@ -3076,6 +3307,12 @@
               </a:rPr>
               <a:t>• Website Live (Production): </a:t>
             </a:r>
+            <a:pPr indent="0" marL="0">
+              <a:lnSpc>
+                <a:spcPts val="1800"/>
+              </a:lnSpc>
+              <a:buNone/>
+            </a:pPr>
             <a:r>
               <a:rPr lang="en-US" sz="1150" b="1" dirty="0">
                 <a:solidFill>
@@ -3088,6 +3325,12 @@
               <a:t>https://meetthink.vercel.app
 </a:t>
             </a:r>
+            <a:pPr indent="0" marL="0">
+              <a:lnSpc>
+                <a:spcPts val="1800"/>
+              </a:lnSpc>
+              <a:buNone/>
+            </a:pPr>
             <a:r>
               <a:rPr lang="en-US" sz="1150" b="1" dirty="0">
                 <a:solidFill>
@@ -3099,6 +3342,12 @@
               </a:rPr>
               <a:t>• Repositori GitHub: </a:t>
             </a:r>
+            <a:pPr indent="0" marL="0">
+              <a:lnSpc>
+                <a:spcPts val="1800"/>
+              </a:lnSpc>
+              <a:buNone/>
+            </a:pPr>
             <a:r>
               <a:rPr lang="en-US" sz="1150" dirty="0">
                 <a:solidFill>
@@ -3111,6 +3360,12 @@
               <a:t>https://github.com/allaboutpampam8-crypto/meetthink
 </a:t>
             </a:r>
+            <a:pPr indent="0" marL="0">
+              <a:lnSpc>
+                <a:spcPts val="1800"/>
+              </a:lnSpc>
+              <a:buNone/>
+            </a:pPr>
             <a:r>
               <a:rPr lang="en-US" sz="1150" b="1" dirty="0">
                 <a:solidFill>
@@ -3122,6 +3377,12 @@
               </a:rPr>
               <a:t>• Akun Super Admin: </a:t>
             </a:r>
+            <a:pPr indent="0" marL="0">
+              <a:lnSpc>
+                <a:spcPts val="1800"/>
+              </a:lnSpc>
+              <a:buNone/>
+            </a:pPr>
             <a:r>
               <a:rPr lang="en-US" sz="1150" dirty="0">
                 <a:solidFill>
@@ -3134,6 +3395,12 @@
               <a:t>superadmin@company.com  /  Admin@1234
 </a:t>
             </a:r>
+            <a:pPr indent="0" marL="0">
+              <a:lnSpc>
+                <a:spcPts val="1800"/>
+              </a:lnSpc>
+              <a:buNone/>
+            </a:pPr>
             <a:r>
               <a:rPr lang="en-US" sz="1150" b="1" dirty="0">
                 <a:solidFill>
@@ -3145,6 +3412,12 @@
               </a:rPr>
               <a:t>• Akun Approver: </a:t>
             </a:r>
+            <a:pPr indent="0" marL="0">
+              <a:lnSpc>
+                <a:spcPts val="1800"/>
+              </a:lnSpc>
+              <a:buNone/>
+            </a:pPr>
             <a:r>
               <a:rPr lang="en-US" sz="1150" dirty="0">
                 <a:solidFill>
@@ -3160,36 +3433,45 @@
           </a:p>
         </p:txBody>
       </p:sp>
-      <p:pic>
-        <p:nvPicPr>
-          <p:cNvPr id="9" name="Picture 8">
-            <a:extLst>
-              <a:ext uri="{FF2B5EF4-FFF2-40B4-BE49-F238E27FC236}">
-                <a16:creationId xmlns:a16="http://schemas.microsoft.com/office/drawing/2014/main" id="{D10B9DFA-85BD-2EF7-19B3-85540C79AFBF}"/>
-              </a:ext>
-            </a:extLst>
-          </p:cNvPr>
-          <p:cNvPicPr>
-            <a:picLocks noChangeAspect="1"/>
-          </p:cNvPicPr>
-          <p:nvPr/>
-        </p:nvPicPr>
-        <p:blipFill>
-          <a:blip r:embed="rId3"/>
-          <a:stretch>
-            <a:fillRect/>
-          </a:stretch>
-        </p:blipFill>
-        <p:spPr>
-          <a:xfrm>
-            <a:off x="5538395" y="356795"/>
-            <a:ext cx="1115209" cy="1115209"/>
-          </a:xfrm>
-          <a:prstGeom prst="rect">
-            <a:avLst/>
-          </a:prstGeom>
-        </p:spPr>
-      </p:pic>
+      <p:sp>
+        <p:nvSpPr>
+          <p:cNvPr id="7" name="Text 5"/>
+          <p:cNvSpPr/>
+          <p:nvPr/>
+        </p:nvSpPr>
+        <p:spPr>
+          <a:xfrm>
+            <a:off x="731520" y="5760720"/>
+            <a:ext cx="10698480" cy="365760"/>
+          </a:xfrm>
+          <a:prstGeom prst="rect">
+            <a:avLst/>
+          </a:prstGeom>
+          <a:noFill/>
+          <a:ln/>
+        </p:spPr>
+        <p:txBody>
+          <a:bodyPr wrap="square" rtlCol="0" anchor="ctr"/>
+          <a:lstStyle/>
+          <a:p>
+            <a:pPr algn="ctr" indent="0" marL="0">
+              <a:buNone/>
+            </a:pPr>
+            <a:r>
+              <a:rPr lang="en-US" sz="1400" b="1" dirty="0">
+                <a:solidFill>
+                  <a:srgbClr val="94A3B8"/>
+                </a:solidFill>
+                <a:latin typeface="Segoe UI" pitchFamily="34" charset="0"/>
+                <a:ea typeface="Segoe UI" pitchFamily="34" charset="-122"/>
+                <a:cs typeface="Segoe UI" pitchFamily="34" charset="-120"/>
+              </a:rPr>
+              <a:t>Sesi Tanya Jawab (Q&amp;A)</a:t>
+            </a:r>
+            <a:endParaRPr lang="en-US" sz="1400" dirty="0"/>
+          </a:p>
+        </p:txBody>
+      </p:sp>
     </p:spTree>
   </p:cSld>
   <p:clrMapOvr>
@@ -3206,7 +3488,6 @@
         <a:solidFill>
           <a:srgbClr val="F8FAFC"/>
         </a:solidFill>
-        <a:effectLst/>
       </p:bgPr>
     </p:bg>
     <p:spTree>
@@ -3271,7 +3552,7 @@
           <a:bodyPr wrap="square" rtlCol="0" anchor="ctr"/>
           <a:lstStyle/>
           <a:p>
-            <a:pPr marL="0" indent="0" algn="ctr">
+            <a:pPr algn="ctr" indent="0" marL="0">
               <a:buNone/>
             </a:pPr>
             <a:r>
@@ -3310,7 +3591,7 @@
           <a:bodyPr wrap="square" rtlCol="0" anchor="t"/>
           <a:lstStyle/>
           <a:p>
-            <a:pPr marL="0" indent="0">
+            <a:pPr indent="0" marL="0">
               <a:buNone/>
             </a:pPr>
             <a:r>
@@ -3369,7 +3650,7 @@
           <a:bodyPr wrap="square" rtlCol="0" anchor="ctr"/>
           <a:lstStyle/>
           <a:p>
-            <a:pPr marL="0" indent="0">
+            <a:pPr indent="0" marL="0">
               <a:buNone/>
             </a:pPr>
             <a:r>
@@ -3479,7 +3760,7 @@
           <a:bodyPr wrap="square" rtlCol="0" anchor="ctr"/>
           <a:lstStyle/>
           <a:p>
-            <a:pPr marL="0" indent="0" algn="ctr">
+            <a:pPr algn="ctr" indent="0" marL="0">
               <a:buNone/>
             </a:pPr>
             <a:r>
@@ -3518,7 +3799,7 @@
           <a:bodyPr wrap="square" rtlCol="0" anchor="ctr"/>
           <a:lstStyle/>
           <a:p>
-            <a:pPr marL="0" indent="0">
+            <a:pPr indent="0" marL="0">
               <a:buNone/>
             </a:pPr>
             <a:r>
@@ -3557,7 +3838,7 @@
           <a:bodyPr wrap="square" rtlCol="0" anchor="ctr"/>
           <a:lstStyle/>
           <a:p>
-            <a:pPr marL="0" indent="0">
+            <a:pPr indent="0" marL="0">
               <a:lnSpc>
                 <a:spcPts val="1600"/>
               </a:lnSpc>
@@ -3670,7 +3951,7 @@
           <a:bodyPr wrap="square" rtlCol="0" anchor="ctr"/>
           <a:lstStyle/>
           <a:p>
-            <a:pPr marL="0" indent="0" algn="ctr">
+            <a:pPr algn="ctr" indent="0" marL="0">
               <a:buNone/>
             </a:pPr>
             <a:r>
@@ -3709,7 +3990,7 @@
           <a:bodyPr wrap="square" rtlCol="0" anchor="ctr"/>
           <a:lstStyle/>
           <a:p>
-            <a:pPr marL="0" indent="0">
+            <a:pPr indent="0" marL="0">
               <a:buNone/>
             </a:pPr>
             <a:r>
@@ -3748,7 +4029,7 @@
           <a:bodyPr wrap="square" rtlCol="0" anchor="ctr"/>
           <a:lstStyle/>
           <a:p>
-            <a:pPr marL="0" indent="0">
+            <a:pPr indent="0" marL="0">
               <a:lnSpc>
                 <a:spcPts val="1600"/>
               </a:lnSpc>
@@ -3861,7 +4142,7 @@
           <a:bodyPr wrap="square" rtlCol="0" anchor="ctr"/>
           <a:lstStyle/>
           <a:p>
-            <a:pPr marL="0" indent="0" algn="ctr">
+            <a:pPr algn="ctr" indent="0" marL="0">
               <a:buNone/>
             </a:pPr>
             <a:r>
@@ -3900,7 +4181,7 @@
           <a:bodyPr wrap="square" rtlCol="0" anchor="ctr"/>
           <a:lstStyle/>
           <a:p>
-            <a:pPr marL="0" indent="0">
+            <a:pPr indent="0" marL="0">
               <a:buNone/>
             </a:pPr>
             <a:r>
@@ -3939,7 +4220,7 @@
           <a:bodyPr wrap="square" rtlCol="0" anchor="ctr"/>
           <a:lstStyle/>
           <a:p>
-            <a:pPr marL="0" indent="0">
+            <a:pPr indent="0" marL="0">
               <a:lnSpc>
                 <a:spcPts val="1600"/>
               </a:lnSpc>
@@ -4052,7 +4333,7 @@
           <a:bodyPr wrap="square" rtlCol="0" anchor="ctr"/>
           <a:lstStyle/>
           <a:p>
-            <a:pPr marL="0" indent="0" algn="ctr">
+            <a:pPr algn="ctr" indent="0" marL="0">
               <a:buNone/>
             </a:pPr>
             <a:r>
@@ -4091,7 +4372,7 @@
           <a:bodyPr wrap="square" rtlCol="0" anchor="ctr"/>
           <a:lstStyle/>
           <a:p>
-            <a:pPr marL="0" indent="0">
+            <a:pPr indent="0" marL="0">
               <a:buNone/>
             </a:pPr>
             <a:r>
@@ -4130,7 +4411,7 @@
           <a:bodyPr wrap="square" rtlCol="0" anchor="ctr"/>
           <a:lstStyle/>
           <a:p>
-            <a:pPr marL="0" indent="0">
+            <a:pPr indent="0" marL="0">
               <a:lnSpc>
                 <a:spcPts val="1600"/>
               </a:lnSpc>
@@ -4167,7 +4448,6 @@
         <a:solidFill>
           <a:srgbClr val="F8FAFC"/>
         </a:solidFill>
-        <a:effectLst/>
       </p:bgPr>
     </p:bg>
     <p:spTree>
@@ -4232,7 +4512,7 @@
           <a:bodyPr wrap="square" rtlCol="0" anchor="ctr"/>
           <a:lstStyle/>
           <a:p>
-            <a:pPr marL="0" indent="0" algn="ctr">
+            <a:pPr algn="ctr" indent="0" marL="0">
               <a:buNone/>
             </a:pPr>
             <a:r>
@@ -4271,7 +4551,7 @@
           <a:bodyPr wrap="square" rtlCol="0" anchor="t"/>
           <a:lstStyle/>
           <a:p>
-            <a:pPr marL="0" indent="0">
+            <a:pPr indent="0" marL="0">
               <a:buNone/>
             </a:pPr>
             <a:r>
@@ -4330,7 +4610,7 @@
           <a:bodyPr wrap="square" rtlCol="0" anchor="ctr"/>
           <a:lstStyle/>
           <a:p>
-            <a:pPr marL="0" indent="0">
+            <a:pPr indent="0" marL="0">
               <a:buNone/>
             </a:pPr>
             <a:r>
@@ -4418,7 +4698,7 @@
           <a:bodyPr wrap="square" rtlCol="0" anchor="ctr"/>
           <a:lstStyle/>
           <a:p>
-            <a:pPr marL="0" indent="0">
+            <a:pPr indent="0" marL="0">
               <a:buNone/>
             </a:pPr>
             <a:r>
@@ -4457,7 +4737,7 @@
           <a:bodyPr wrap="square" rtlCol="0" anchor="ctr"/>
           <a:lstStyle/>
           <a:p>
-            <a:pPr marL="0" indent="0">
+            <a:pPr indent="0" marL="0">
               <a:buNone/>
             </a:pPr>
             <a:r>
@@ -4496,7 +4776,7 @@
           <a:bodyPr wrap="square" rtlCol="0" anchor="ctr"/>
           <a:lstStyle/>
           <a:p>
-            <a:pPr marL="0" indent="0">
+            <a:pPr indent="0" marL="0">
               <a:buNone/>
             </a:pPr>
             <a:r>
@@ -4508,7 +4788,7 @@
                 <a:ea typeface="Segoe UI" pitchFamily="34" charset="-122"/>
                 <a:cs typeface="Segoe UI" pitchFamily="34" charset="-120"/>
               </a:rPr>
-              <a:t>Smart Booking System</a:t>
+              <a:t>Smart Booking &amp; Availability</a:t>
             </a:r>
             <a:endParaRPr lang="en-US" sz="1500" dirty="0"/>
           </a:p>
@@ -4555,7 +4835,7 @@
           <a:bodyPr wrap="square" rtlCol="0" anchor="ctr"/>
           <a:lstStyle/>
           <a:p>
-            <a:pPr marL="0" indent="0">
+            <a:pPr indent="0" marL="0">
               <a:lnSpc>
                 <a:spcPts val="1700"/>
               </a:lnSpc>
@@ -4570,7 +4850,7 @@
                 <a:ea typeface="Segoe UI" pitchFamily="34" charset="-122"/>
                 <a:cs typeface="Segoe UI" pitchFamily="34" charset="-120"/>
               </a:rPr>
-              <a:t>Pemesanan ruangan interaktif dengan algoritma deteksi bentrok otomatis dan katalog fasilitas komprehensif.</a:t>
+              <a:t>Deteksi bentrok ruangan otomatis dan peringatan dini ketersediaan jadwal peserta (pegawai).</a:t>
             </a:r>
             <a:endParaRPr lang="en-US" sz="1150" dirty="0"/>
           </a:p>
@@ -4646,7 +4926,7 @@
           <a:bodyPr wrap="square" rtlCol="0" anchor="ctr"/>
           <a:lstStyle/>
           <a:p>
-            <a:pPr marL="0" indent="0">
+            <a:pPr indent="0" marL="0">
               <a:buNone/>
             </a:pPr>
             <a:r>
@@ -4685,7 +4965,7 @@
           <a:bodyPr wrap="square" rtlCol="0" anchor="ctr"/>
           <a:lstStyle/>
           <a:p>
-            <a:pPr marL="0" indent="0">
+            <a:pPr indent="0" marL="0">
               <a:buNone/>
             </a:pPr>
             <a:r>
@@ -4724,7 +5004,7 @@
           <a:bodyPr wrap="square" rtlCol="0" anchor="ctr"/>
           <a:lstStyle/>
           <a:p>
-            <a:pPr marL="0" indent="0">
+            <a:pPr indent="0" marL="0">
               <a:buNone/>
             </a:pPr>
             <a:r>
@@ -4783,7 +5063,7 @@
           <a:bodyPr wrap="square" rtlCol="0" anchor="ctr"/>
           <a:lstStyle/>
           <a:p>
-            <a:pPr marL="0" indent="0">
+            <a:pPr indent="0" marL="0">
               <a:lnSpc>
                 <a:spcPts val="1700"/>
               </a:lnSpc>
@@ -4874,7 +5154,7 @@
           <a:bodyPr wrap="square" rtlCol="0" anchor="ctr"/>
           <a:lstStyle/>
           <a:p>
-            <a:pPr marL="0" indent="0">
+            <a:pPr indent="0" marL="0">
               <a:buNone/>
             </a:pPr>
             <a:r>
@@ -4913,7 +5193,7 @@
           <a:bodyPr wrap="square" rtlCol="0" anchor="ctr"/>
           <a:lstStyle/>
           <a:p>
-            <a:pPr marL="0" indent="0">
+            <a:pPr indent="0" marL="0">
               <a:buNone/>
             </a:pPr>
             <a:r>
@@ -4952,7 +5232,7 @@
           <a:bodyPr wrap="square" rtlCol="0" anchor="ctr"/>
           <a:lstStyle/>
           <a:p>
-            <a:pPr marL="0" indent="0">
+            <a:pPr indent="0" marL="0">
               <a:buNone/>
             </a:pPr>
             <a:r>
@@ -5011,7 +5291,7 @@
           <a:bodyPr wrap="square" rtlCol="0" anchor="ctr"/>
           <a:lstStyle/>
           <a:p>
-            <a:pPr marL="0" indent="0">
+            <a:pPr indent="0" marL="0">
               <a:lnSpc>
                 <a:spcPts val="1700"/>
               </a:lnSpc>
@@ -5102,7 +5382,7 @@
           <a:bodyPr wrap="square" rtlCol="0" anchor="ctr"/>
           <a:lstStyle/>
           <a:p>
-            <a:pPr marL="0" indent="0">
+            <a:pPr indent="0" marL="0">
               <a:buNone/>
             </a:pPr>
             <a:r>
@@ -5141,7 +5421,7 @@
           <a:bodyPr wrap="square" rtlCol="0" anchor="ctr"/>
           <a:lstStyle/>
           <a:p>
-            <a:pPr marL="0" indent="0">
+            <a:pPr indent="0" marL="0">
               <a:buNone/>
             </a:pPr>
             <a:r>
@@ -5180,7 +5460,7 @@
           <a:bodyPr wrap="square" rtlCol="0" anchor="ctr"/>
           <a:lstStyle/>
           <a:p>
-            <a:pPr marL="0" indent="0">
+            <a:pPr indent="0" marL="0">
               <a:buNone/>
             </a:pPr>
             <a:r>
@@ -5239,7 +5519,7 @@
           <a:bodyPr wrap="square" rtlCol="0" anchor="ctr"/>
           <a:lstStyle/>
           <a:p>
-            <a:pPr marL="0" indent="0">
+            <a:pPr indent="0" marL="0">
               <a:lnSpc>
                 <a:spcPts val="1700"/>
               </a:lnSpc>
@@ -5276,7 +5556,6 @@
         <a:solidFill>
           <a:srgbClr val="F8FAFC"/>
         </a:solidFill>
-        <a:effectLst/>
       </p:bgPr>
     </p:bg>
     <p:spTree>
@@ -5341,7 +5620,7 @@
           <a:bodyPr wrap="square" rtlCol="0" anchor="ctr"/>
           <a:lstStyle/>
           <a:p>
-            <a:pPr marL="0" indent="0" algn="ctr">
+            <a:pPr algn="ctr" indent="0" marL="0">
               <a:buNone/>
             </a:pPr>
             <a:r>
@@ -5380,7 +5659,7 @@
           <a:bodyPr wrap="square" rtlCol="0" anchor="t"/>
           <a:lstStyle/>
           <a:p>
-            <a:pPr marL="0" indent="0">
+            <a:pPr indent="0" marL="0">
               <a:buNone/>
             </a:pPr>
             <a:r>
@@ -5392,7 +5671,7 @@
                 <a:ea typeface="Segoe UI" pitchFamily="34" charset="-122"/>
                 <a:cs typeface="Segoe UI" pitchFamily="34" charset="-120"/>
               </a:rPr>
-              <a:t>Fitur 1: Pemesanan Ruangan &amp; Deteksi Bentrok Instan</a:t>
+              <a:t>Fitur 1: Pemesanan Ruangan &amp; Proteksi Bentrok Ganda</a:t>
             </a:r>
             <a:endParaRPr lang="en-US" sz="2200" dirty="0"/>
           </a:p>
@@ -5439,7 +5718,7 @@
           <a:bodyPr wrap="square" rtlCol="0" anchor="ctr"/>
           <a:lstStyle/>
           <a:p>
-            <a:pPr marL="0" indent="0">
+            <a:pPr indent="0" marL="0">
               <a:buNone/>
             </a:pPr>
             <a:r>
@@ -5525,7 +5804,7 @@
           <a:bodyPr wrap="square" rtlCol="0" anchor="ctr"/>
           <a:lstStyle/>
           <a:p>
-            <a:pPr marL="0" indent="0">
+            <a:pPr indent="0" marL="0">
               <a:buNone/>
             </a:pPr>
             <a:r>
@@ -5537,7 +5816,7 @@
                 <a:ea typeface="Segoe UI" pitchFamily="34" charset="-122"/>
                 <a:cs typeface="Segoe UI" pitchFamily="34" charset="-120"/>
               </a:rPr>
-              <a:t>Deteksi Bentrok Jadwal Otomatis (Conflict Check)</a:t>
+              <a:t>Pencegahan Bentrok Ruangan (Room Conflict Check)</a:t>
             </a:r>
             <a:endParaRPr lang="en-US" sz="1300" dirty="0"/>
           </a:p>
@@ -5564,7 +5843,7 @@
           <a:bodyPr wrap="square" rtlCol="0" anchor="ctr"/>
           <a:lstStyle/>
           <a:p>
-            <a:pPr marL="0" indent="0">
+            <a:pPr indent="0" marL="0">
               <a:lnSpc>
                 <a:spcPts val="1500"/>
               </a:lnSpc>
@@ -5579,7 +5858,7 @@
                 <a:ea typeface="Segoe UI" pitchFamily="34" charset="-122"/>
                 <a:cs typeface="Segoe UI" pitchFamily="34" charset="-120"/>
               </a:rPr>
-              <a:t>Sistem secara otomatis mengevaluasi interval waktu yang dipilih. Jika ruangan sudah dipesan pada jam tersebut, pengajuan langsung dicegah sebelum dikirim.</a:t>
+              <a:t>Sistem mengevaluasi interval waktu secara otomatis. Jika ruangan sudah terpakai pada jam tersebut, pengajuan langsung dicegah sebelum submit.</a:t>
             </a:r>
             <a:endParaRPr lang="en-US" sz="1050" dirty="0"/>
           </a:p>
@@ -5626,7 +5905,7 @@
           <a:bodyPr wrap="square" rtlCol="0" anchor="ctr"/>
           <a:lstStyle/>
           <a:p>
-            <a:pPr marL="0" indent="0">
+            <a:pPr indent="0" marL="0">
               <a:buNone/>
             </a:pPr>
             <a:r>
@@ -5638,7 +5917,7 @@
                 <a:ea typeface="Segoe UI" pitchFamily="34" charset="-122"/>
                 <a:cs typeface="Segoe UI" pitchFamily="34" charset="-120"/>
               </a:rPr>
-              <a:t>Katalog Ruangan Komprehensif</a:t>
+              <a:t>Peringatan Jadwal Pegawai (Participant Conflict Advisory)</a:t>
             </a:r>
             <a:endParaRPr lang="en-US" sz="1300" dirty="0"/>
           </a:p>
@@ -5665,7 +5944,7 @@
           <a:bodyPr wrap="square" rtlCol="0" anchor="ctr"/>
           <a:lstStyle/>
           <a:p>
-            <a:pPr marL="0" indent="0">
+            <a:pPr indent="0" marL="0">
               <a:lnSpc>
                 <a:spcPts val="1500"/>
               </a:lnSpc>
@@ -5680,7 +5959,7 @@
                 <a:ea typeface="Segoe UI" pitchFamily="34" charset="-122"/>
                 <a:cs typeface="Segoe UI" pitchFamily="34" charset="-120"/>
               </a:rPr>
-              <a:t>Mencakup kapasitas peserta, denah gedung, lantai, foto ruangan, dan kelengkapan fasilitas (TV/Monitor, Proyektor, Video Conf, AC, Sound System).</a:t>
+              <a:t>Memberikan peringatan visual instan jika peserta yang diundang sudah memiliki agenda rapat lain di jam yang sama, lengkap dengan rincian jadwal yang bentrok.</a:t>
             </a:r>
             <a:endParaRPr lang="en-US" sz="1050" dirty="0"/>
           </a:p>
@@ -5727,7 +6006,7 @@
           <a:bodyPr wrap="square" rtlCol="0" anchor="ctr"/>
           <a:lstStyle/>
           <a:p>
-            <a:pPr marL="0" indent="0">
+            <a:pPr indent="0" marL="0">
               <a:buNone/>
             </a:pPr>
             <a:r>
@@ -5739,7 +6018,7 @@
                 <a:ea typeface="Segoe UI" pitchFamily="34" charset="-122"/>
                 <a:cs typeface="Segoe UI" pitchFamily="34" charset="-120"/>
               </a:rPr>
-              <a:t>Integrasi Fasilitas Khusus &amp; Konsumsi</a:t>
+              <a:t>Katalog Ruangan Komprehensif</a:t>
             </a:r>
             <a:endParaRPr lang="en-US" sz="1300" dirty="0"/>
           </a:p>
@@ -5766,7 +6045,7 @@
           <a:bodyPr wrap="square" rtlCol="0" anchor="ctr"/>
           <a:lstStyle/>
           <a:p>
-            <a:pPr marL="0" indent="0">
+            <a:pPr indent="0" marL="0">
               <a:lnSpc>
                 <a:spcPts val="1500"/>
               </a:lnSpc>
@@ -5781,7 +6060,7 @@
                 <a:ea typeface="Segoe UI" pitchFamily="34" charset="-122"/>
                 <a:cs typeface="Segoe UI" pitchFamily="34" charset="-120"/>
               </a:rPr>
-              <a:t>Pemohon dapat langsung meminta konsumsi rapat (snack/makan siang) dan setup IT khusus dalam satu formulir pemesanan.</a:t>
+              <a:t>Mencakup kapasitas peserta, denah gedung, lantai, foto ruangan, dan kelengkapan fasilitas (TV/Monitor, Proyektor, Video Conf, AC, Sound System).</a:t>
             </a:r>
             <a:endParaRPr lang="en-US" sz="1050" dirty="0"/>
           </a:p>
@@ -5828,7 +6107,7 @@
           <a:bodyPr wrap="square" rtlCol="0" anchor="ctr"/>
           <a:lstStyle/>
           <a:p>
-            <a:pPr marL="0" indent="0">
+            <a:pPr indent="0" marL="0">
               <a:buNone/>
             </a:pPr>
             <a:r>
@@ -5840,7 +6119,7 @@
                 <a:ea typeface="Segoe UI" pitchFamily="34" charset="-122"/>
                 <a:cs typeface="Segoe UI" pitchFamily="34" charset="-120"/>
               </a:rPr>
-              <a:t>Visualisasi Kalender Fleksibel</a:t>
+              <a:t>Integrasi Fasilitas Khusus, Konsumsi &amp; Timeline</a:t>
             </a:r>
             <a:endParaRPr lang="en-US" sz="1300" dirty="0"/>
           </a:p>
@@ -5867,7 +6146,7 @@
           <a:bodyPr wrap="square" rtlCol="0" anchor="ctr"/>
           <a:lstStyle/>
           <a:p>
-            <a:pPr marL="0" indent="0">
+            <a:pPr indent="0" marL="0">
               <a:lnSpc>
                 <a:spcPts val="1500"/>
               </a:lnSpc>
@@ -5882,7 +6161,7 @@
                 <a:ea typeface="Segoe UI" pitchFamily="34" charset="-122"/>
                 <a:cs typeface="Segoe UI" pitchFamily="34" charset="-120"/>
               </a:rPr>
-              <a:t>Tampilan kalender terintegrasi dalam format Harian (Timeline per ruang), Mingguan, dan Bulanan untuk memudahkan perencanaan tim.</a:t>
+              <a:t>Request konsumsi rapat dan peralatan IT dalam satu formulir, dilengkapi visualisasi jadwal harian (timeline) per ruangan.</a:t>
             </a:r>
             <a:endParaRPr lang="en-US" sz="1050" dirty="0"/>
           </a:p>
@@ -5931,7 +6210,7 @@
           <a:bodyPr wrap="square" rtlCol="0" anchor="ctr"/>
           <a:lstStyle/>
           <a:p>
-            <a:pPr marL="0" indent="0">
+            <a:pPr indent="0" marL="0">
               <a:buNone/>
             </a:pPr>
             <a:r>
@@ -5943,7 +6222,7 @@
                 <a:ea typeface="Segoe UI" pitchFamily="34" charset="-122"/>
                 <a:cs typeface="Segoe UI" pitchFamily="34" charset="-120"/>
               </a:rPr>
-              <a:t>NILAI UNGGULAN</a:t>
+              <a:t>PROTEKSI BENTROK GANDA</a:t>
             </a:r>
             <a:endParaRPr lang="en-US" sz="1000" dirty="0"/>
           </a:p>
@@ -5970,7 +6249,7 @@
           <a:bodyPr wrap="square" rtlCol="0" anchor="ctr"/>
           <a:lstStyle/>
           <a:p>
-            <a:pPr marL="0" indent="0">
+            <a:pPr indent="0" marL="0">
               <a:buNone/>
             </a:pPr>
             <a:r>
@@ -5982,7 +6261,7 @@
                 <a:ea typeface="Segoe UI" pitchFamily="34" charset="-122"/>
                 <a:cs typeface="Segoe UI" pitchFamily="34" charset="-120"/>
               </a:rPr>
-              <a:t>Nol Insiden Dual-Booking</a:t>
+              <a:t>Ruangan &amp; Pegawai Aman</a:t>
             </a:r>
             <a:endParaRPr lang="en-US" sz="2200" dirty="0"/>
           </a:p>
@@ -6009,7 +6288,7 @@
           <a:bodyPr wrap="square" rtlCol="0" anchor="ctr"/>
           <a:lstStyle/>
           <a:p>
-            <a:pPr marL="0" indent="0">
+            <a:pPr indent="0" marL="0">
               <a:lnSpc>
                 <a:spcPts val="1800"/>
               </a:lnSpc>
@@ -6024,7 +6303,7 @@
                 <a:ea typeface="Segoe UI" pitchFamily="34" charset="-122"/>
                 <a:cs typeface="Segoe UI" pitchFamily="34" charset="-120"/>
               </a:rPr>
-              <a:t>Algoritma pengecekan tumpang tindih matematis menjamin tidak ada dua unit kerja yang dapat memesan ruangan yang sama di waktu bersamaan.</a:t>
+              <a:t>Sistem tidak hanya mencegah tumpang tindih penggunaan fasilitas fisik, tetapi juga melindungi jadwal kerja pegawai dari penumpukan rapat di jam yang sama.</a:t>
             </a:r>
             <a:endParaRPr lang="en-US" sz="1200" dirty="0"/>
           </a:p>
@@ -6078,7 +6357,7 @@
           <a:bodyPr wrap="square" rtlCol="0" anchor="ctr"/>
           <a:lstStyle/>
           <a:p>
-            <a:pPr marL="0" indent="0">
+            <a:pPr indent="0" marL="0">
               <a:buNone/>
             </a:pPr>
             <a:r>
@@ -6093,6 +6372,9 @@
               <a:t>Ketersediaan Real-Time
 </a:t>
             </a:r>
+            <a:pPr indent="0" marL="0">
+              <a:buNone/>
+            </a:pPr>
             <a:r>
               <a:rPr lang="en-US" sz="1100" dirty="0">
                 <a:solidFill>
@@ -6124,7 +6406,6 @@
         <a:solidFill>
           <a:srgbClr val="F8FAFC"/>
         </a:solidFill>
-        <a:effectLst/>
       </p:bgPr>
     </p:bg>
     <p:spTree>
@@ -6189,7 +6470,7 @@
           <a:bodyPr wrap="square" rtlCol="0" anchor="ctr"/>
           <a:lstStyle/>
           <a:p>
-            <a:pPr marL="0" indent="0" algn="ctr">
+            <a:pPr algn="ctr" indent="0" marL="0">
               <a:buNone/>
             </a:pPr>
             <a:r>
@@ -6228,7 +6509,7 @@
           <a:bodyPr wrap="square" rtlCol="0" anchor="t"/>
           <a:lstStyle/>
           <a:p>
-            <a:pPr marL="0" indent="0">
+            <a:pPr indent="0" marL="0">
               <a:buNone/>
             </a:pPr>
             <a:r>
@@ -6287,7 +6568,7 @@
           <a:bodyPr wrap="square" rtlCol="0" anchor="ctr"/>
           <a:lstStyle/>
           <a:p>
-            <a:pPr marL="0" indent="0">
+            <a:pPr indent="0" marL="0">
               <a:buNone/>
             </a:pPr>
             <a:r>
@@ -6353,7 +6634,7 @@
           <a:bodyPr wrap="square" rtlCol="0" anchor="ctr"/>
           <a:lstStyle/>
           <a:p>
-            <a:pPr marL="0" indent="0">
+            <a:pPr indent="0" marL="0">
               <a:buNone/>
             </a:pPr>
             <a:r>
@@ -6392,7 +6673,7 @@
           <a:bodyPr wrap="square" rtlCol="0" anchor="ctr"/>
           <a:lstStyle/>
           <a:p>
-            <a:pPr marL="0" indent="0">
+            <a:pPr indent="0" marL="0">
               <a:buNone/>
             </a:pPr>
             <a:r>
@@ -6431,7 +6712,7 @@
           <a:bodyPr wrap="square" rtlCol="0" anchor="ctr"/>
           <a:lstStyle/>
           <a:p>
-            <a:pPr marL="0" indent="0">
+            <a:pPr indent="0" marL="0">
               <a:buNone/>
             </a:pPr>
             <a:r>
@@ -6470,7 +6751,7 @@
           <a:bodyPr wrap="square" rtlCol="0" anchor="ctr"/>
           <a:lstStyle/>
           <a:p>
-            <a:pPr marL="0" indent="0">
+            <a:pPr indent="0" marL="0">
               <a:lnSpc>
                 <a:spcPts val="1500"/>
               </a:lnSpc>
@@ -6539,7 +6820,7 @@
           <a:bodyPr wrap="square" rtlCol="0" anchor="ctr"/>
           <a:lstStyle/>
           <a:p>
-            <a:pPr marL="0" indent="0">
+            <a:pPr indent="0" marL="0">
               <a:buNone/>
             </a:pPr>
             <a:r>
@@ -6578,7 +6859,7 @@
           <a:bodyPr wrap="square" rtlCol="0" anchor="ctr"/>
           <a:lstStyle/>
           <a:p>
-            <a:pPr marL="0" indent="0">
+            <a:pPr indent="0" marL="0">
               <a:buNone/>
             </a:pPr>
             <a:r>
@@ -6617,7 +6898,7 @@
           <a:bodyPr wrap="square" rtlCol="0" anchor="ctr"/>
           <a:lstStyle/>
           <a:p>
-            <a:pPr marL="0" indent="0">
+            <a:pPr indent="0" marL="0">
               <a:buNone/>
             </a:pPr>
             <a:r>
@@ -6656,7 +6937,7 @@
           <a:bodyPr wrap="square" rtlCol="0" anchor="ctr"/>
           <a:lstStyle/>
           <a:p>
-            <a:pPr marL="0" indent="0">
+            <a:pPr indent="0" marL="0">
               <a:lnSpc>
                 <a:spcPts val="1500"/>
               </a:lnSpc>
@@ -6725,7 +7006,7 @@
           <a:bodyPr wrap="square" rtlCol="0" anchor="ctr"/>
           <a:lstStyle/>
           <a:p>
-            <a:pPr marL="0" indent="0">
+            <a:pPr indent="0" marL="0">
               <a:buNone/>
             </a:pPr>
             <a:r>
@@ -6764,7 +7045,7 @@
           <a:bodyPr wrap="square" rtlCol="0" anchor="ctr"/>
           <a:lstStyle/>
           <a:p>
-            <a:pPr marL="0" indent="0">
+            <a:pPr indent="0" marL="0">
               <a:buNone/>
             </a:pPr>
             <a:r>
@@ -6803,7 +7084,7 @@
           <a:bodyPr wrap="square" rtlCol="0" anchor="ctr"/>
           <a:lstStyle/>
           <a:p>
-            <a:pPr marL="0" indent="0">
+            <a:pPr indent="0" marL="0">
               <a:buNone/>
             </a:pPr>
             <a:r>
@@ -6842,7 +7123,7 @@
           <a:bodyPr wrap="square" rtlCol="0" anchor="ctr"/>
           <a:lstStyle/>
           <a:p>
-            <a:pPr marL="0" indent="0">
+            <a:pPr indent="0" marL="0">
               <a:lnSpc>
                 <a:spcPts val="1500"/>
               </a:lnSpc>
@@ -6911,7 +7192,7 @@
           <a:bodyPr wrap="square" rtlCol="0" anchor="ctr"/>
           <a:lstStyle/>
           <a:p>
-            <a:pPr marL="0" indent="0">
+            <a:pPr indent="0" marL="0">
               <a:buNone/>
             </a:pPr>
             <a:r>
@@ -6950,7 +7231,7 @@
           <a:bodyPr wrap="square" rtlCol="0" anchor="ctr"/>
           <a:lstStyle/>
           <a:p>
-            <a:pPr marL="0" indent="0">
+            <a:pPr indent="0" marL="0">
               <a:buNone/>
             </a:pPr>
             <a:r>
@@ -6989,7 +7270,7 @@
           <a:bodyPr wrap="square" rtlCol="0" anchor="ctr"/>
           <a:lstStyle/>
           <a:p>
-            <a:pPr marL="0" indent="0">
+            <a:pPr indent="0" marL="0">
               <a:buNone/>
             </a:pPr>
             <a:r>
@@ -7028,7 +7309,7 @@
           <a:bodyPr wrap="square" rtlCol="0" anchor="ctr"/>
           <a:lstStyle/>
           <a:p>
-            <a:pPr marL="0" indent="0">
+            <a:pPr indent="0" marL="0">
               <a:lnSpc>
                 <a:spcPts val="1500"/>
               </a:lnSpc>
@@ -7097,7 +7378,7 @@
           <a:bodyPr wrap="square" rtlCol="0" anchor="ctr"/>
           <a:lstStyle/>
           <a:p>
-            <a:pPr marL="0" indent="0">
+            <a:pPr indent="0" marL="0">
               <a:buNone/>
             </a:pPr>
             <a:r>
@@ -7136,7 +7417,7 @@
           <a:bodyPr wrap="square" rtlCol="0" anchor="ctr"/>
           <a:lstStyle/>
           <a:p>
-            <a:pPr marL="0" indent="0">
+            <a:pPr indent="0" marL="0">
               <a:lnSpc>
                 <a:spcPts val="1800"/>
               </a:lnSpc>
@@ -7156,7 +7437,7 @@
             <a:endParaRPr lang="en-US" sz="1150" dirty="0"/>
           </a:p>
           <a:p>
-            <a:pPr marL="0" indent="0">
+            <a:pPr indent="0" marL="0">
               <a:lnSpc>
                 <a:spcPts val="1800"/>
               </a:lnSpc>
@@ -7193,7 +7474,6 @@
         <a:solidFill>
           <a:srgbClr val="F8FAFC"/>
         </a:solidFill>
-        <a:effectLst/>
       </p:bgPr>
     </p:bg>
     <p:spTree>
@@ -7258,7 +7538,7 @@
           <a:bodyPr wrap="square" rtlCol="0" anchor="ctr"/>
           <a:lstStyle/>
           <a:p>
-            <a:pPr marL="0" indent="0" algn="ctr">
+            <a:pPr algn="ctr" indent="0" marL="0">
               <a:buNone/>
             </a:pPr>
             <a:r>
@@ -7297,7 +7577,7 @@
           <a:bodyPr wrap="square" rtlCol="0" anchor="t"/>
           <a:lstStyle/>
           <a:p>
-            <a:pPr marL="0" indent="0">
+            <a:pPr indent="0" marL="0">
               <a:buNone/>
             </a:pPr>
             <a:r>
@@ -7356,7 +7636,7 @@
           <a:bodyPr wrap="square" rtlCol="0" anchor="ctr"/>
           <a:lstStyle/>
           <a:p>
-            <a:pPr marL="0" indent="0">
+            <a:pPr indent="0" marL="0">
               <a:buNone/>
             </a:pPr>
             <a:r>
@@ -7422,7 +7702,7 @@
           <a:bodyPr wrap="square" rtlCol="0" anchor="ctr"/>
           <a:lstStyle/>
           <a:p>
-            <a:pPr marL="0" indent="0">
+            <a:pPr indent="0" marL="0">
               <a:buNone/>
             </a:pPr>
             <a:r>
@@ -7461,7 +7741,7 @@
           <a:bodyPr wrap="square" rtlCol="0" anchor="ctr"/>
           <a:lstStyle/>
           <a:p>
-            <a:pPr marL="0" indent="0">
+            <a:pPr indent="0" marL="0">
               <a:buNone/>
             </a:pPr>
             <a:r>
@@ -7500,7 +7780,7 @@
           <a:bodyPr wrap="square" rtlCol="0" anchor="ctr"/>
           <a:lstStyle/>
           <a:p>
-            <a:pPr marL="0" indent="0">
+            <a:pPr indent="0" marL="0">
               <a:lnSpc>
                 <a:spcPts val="1500"/>
               </a:lnSpc>
@@ -7569,7 +7849,7 @@
           <a:bodyPr wrap="square" rtlCol="0" anchor="ctr"/>
           <a:lstStyle/>
           <a:p>
-            <a:pPr marL="0" indent="0">
+            <a:pPr indent="0" marL="0">
               <a:buNone/>
             </a:pPr>
             <a:r>
@@ -7608,7 +7888,7 @@
           <a:bodyPr wrap="square" rtlCol="0" anchor="ctr"/>
           <a:lstStyle/>
           <a:p>
-            <a:pPr marL="0" indent="0">
+            <a:pPr indent="0" marL="0">
               <a:buNone/>
             </a:pPr>
             <a:r>
@@ -7647,7 +7927,7 @@
           <a:bodyPr wrap="square" rtlCol="0" anchor="ctr"/>
           <a:lstStyle/>
           <a:p>
-            <a:pPr marL="0" indent="0">
+            <a:pPr indent="0" marL="0">
               <a:lnSpc>
                 <a:spcPts val="1500"/>
               </a:lnSpc>
@@ -7716,7 +7996,7 @@
           <a:bodyPr wrap="square" rtlCol="0" anchor="ctr"/>
           <a:lstStyle/>
           <a:p>
-            <a:pPr marL="0" indent="0">
+            <a:pPr indent="0" marL="0">
               <a:buNone/>
             </a:pPr>
             <a:r>
@@ -7755,7 +8035,7 @@
           <a:bodyPr wrap="square" rtlCol="0" anchor="ctr"/>
           <a:lstStyle/>
           <a:p>
-            <a:pPr marL="0" indent="0">
+            <a:pPr indent="0" marL="0">
               <a:buNone/>
             </a:pPr>
             <a:r>
@@ -7794,7 +8074,7 @@
           <a:bodyPr wrap="square" rtlCol="0" anchor="ctr"/>
           <a:lstStyle/>
           <a:p>
-            <a:pPr marL="0" indent="0">
+            <a:pPr indent="0" marL="0">
               <a:lnSpc>
                 <a:spcPts val="1500"/>
               </a:lnSpc>
@@ -7858,7 +8138,7 @@
           <a:bodyPr wrap="square" rtlCol="0" anchor="ctr"/>
           <a:lstStyle/>
           <a:p>
-            <a:pPr marL="0" indent="0">
+            <a:pPr indent="0" marL="0">
               <a:buNone/>
             </a:pPr>
             <a:r>
@@ -7897,7 +8177,7 @@
           <a:bodyPr wrap="square" rtlCol="0" anchor="ctr"/>
           <a:lstStyle/>
           <a:p>
-            <a:pPr marL="0" indent="0">
+            <a:pPr indent="0" marL="0">
               <a:buNone/>
             </a:pPr>
             <a:r>
@@ -7936,7 +8216,7 @@
           <a:bodyPr wrap="square" rtlCol="0" anchor="ctr"/>
           <a:lstStyle/>
           <a:p>
-            <a:pPr marL="0" indent="0">
+            <a:pPr indent="0" marL="0">
               <a:lnSpc>
                 <a:spcPts val="1800"/>
               </a:lnSpc>
@@ -8005,7 +8285,7 @@
           <a:bodyPr wrap="square" rtlCol="0" anchor="ctr"/>
           <a:lstStyle/>
           <a:p>
-            <a:pPr marL="0" indent="0">
+            <a:pPr indent="0" marL="0">
               <a:buNone/>
             </a:pPr>
             <a:r>
@@ -8020,6 +8300,9 @@
               <a:t>Kategori Kehadiran:
 </a:t>
             </a:r>
+            <a:pPr indent="0" marL="0">
+              <a:buNone/>
+            </a:pPr>
             <a:r>
               <a:rPr lang="en-US" sz="1100" dirty="0">
                 <a:solidFill>
@@ -8032,6 +8315,9 @@
               <a:t>• Tepat Waktu / Terlambat
 </a:t>
             </a:r>
+            <a:pPr indent="0" marL="0">
+              <a:buNone/>
+            </a:pPr>
             <a:r>
               <a:rPr lang="en-US" sz="1100" b="1" dirty="0">
                 <a:solidFill>
@@ -8063,7 +8349,6 @@
         <a:solidFill>
           <a:srgbClr val="F8FAFC"/>
         </a:solidFill>
-        <a:effectLst/>
       </p:bgPr>
     </p:bg>
     <p:spTree>
@@ -8128,7 +8413,7 @@
           <a:bodyPr wrap="square" rtlCol="0" anchor="ctr"/>
           <a:lstStyle/>
           <a:p>
-            <a:pPr marL="0" indent="0" algn="ctr">
+            <a:pPr algn="ctr" indent="0" marL="0">
               <a:buNone/>
             </a:pPr>
             <a:r>
@@ -8167,7 +8452,7 @@
           <a:bodyPr wrap="square" rtlCol="0" anchor="t"/>
           <a:lstStyle/>
           <a:p>
-            <a:pPr marL="0" indent="0">
+            <a:pPr indent="0" marL="0">
               <a:buNone/>
             </a:pPr>
             <a:r>
@@ -8226,7 +8511,7 @@
           <a:bodyPr wrap="square" rtlCol="0" anchor="ctr"/>
           <a:lstStyle/>
           <a:p>
-            <a:pPr marL="0" indent="0">
+            <a:pPr indent="0" marL="0">
               <a:buNone/>
             </a:pPr>
             <a:r>
@@ -8317,7 +8602,7 @@
           <a:bodyPr wrap="square" rtlCol="0" anchor="ctr"/>
           <a:lstStyle/>
           <a:p>
-            <a:pPr marL="0" indent="0" algn="ctr">
+            <a:pPr algn="ctr" indent="0" marL="0">
               <a:buNone/>
             </a:pPr>
             <a:r>
@@ -8356,7 +8641,7 @@
           <a:bodyPr wrap="square" rtlCol="0" anchor="ctr"/>
           <a:lstStyle/>
           <a:p>
-            <a:pPr marL="0" indent="0">
+            <a:pPr indent="0" marL="0">
               <a:buNone/>
             </a:pPr>
             <a:r>
@@ -8395,7 +8680,7 @@
           <a:bodyPr wrap="square" rtlCol="0" anchor="ctr"/>
           <a:lstStyle/>
           <a:p>
-            <a:pPr marL="0" indent="0">
+            <a:pPr indent="0" marL="0">
               <a:lnSpc>
                 <a:spcPts val="1600"/>
               </a:lnSpc>
@@ -8489,7 +8774,7 @@
           <a:bodyPr wrap="square" rtlCol="0" anchor="ctr"/>
           <a:lstStyle/>
           <a:p>
-            <a:pPr marL="0" indent="0" algn="ctr">
+            <a:pPr algn="ctr" indent="0" marL="0">
               <a:buNone/>
             </a:pPr>
             <a:r>
@@ -8528,7 +8813,7 @@
           <a:bodyPr wrap="square" rtlCol="0" anchor="ctr"/>
           <a:lstStyle/>
           <a:p>
-            <a:pPr marL="0" indent="0">
+            <a:pPr indent="0" marL="0">
               <a:buNone/>
             </a:pPr>
             <a:r>
@@ -8567,7 +8852,7 @@
           <a:bodyPr wrap="square" rtlCol="0" anchor="ctr"/>
           <a:lstStyle/>
           <a:p>
-            <a:pPr marL="0" indent="0">
+            <a:pPr indent="0" marL="0">
               <a:lnSpc>
                 <a:spcPts val="1600"/>
               </a:lnSpc>
@@ -8661,7 +8946,7 @@
           <a:bodyPr wrap="square" rtlCol="0" anchor="ctr"/>
           <a:lstStyle/>
           <a:p>
-            <a:pPr marL="0" indent="0" algn="ctr">
+            <a:pPr algn="ctr" indent="0" marL="0">
               <a:buNone/>
             </a:pPr>
             <a:r>
@@ -8700,7 +8985,7 @@
           <a:bodyPr wrap="square" rtlCol="0" anchor="ctr"/>
           <a:lstStyle/>
           <a:p>
-            <a:pPr marL="0" indent="0">
+            <a:pPr indent="0" marL="0">
               <a:buNone/>
             </a:pPr>
             <a:r>
@@ -8739,7 +9024,7 @@
           <a:bodyPr wrap="square" rtlCol="0" anchor="ctr"/>
           <a:lstStyle/>
           <a:p>
-            <a:pPr marL="0" indent="0">
+            <a:pPr indent="0" marL="0">
               <a:lnSpc>
                 <a:spcPts val="1600"/>
               </a:lnSpc>
@@ -8833,7 +9118,7 @@
           <a:bodyPr wrap="square" rtlCol="0" anchor="ctr"/>
           <a:lstStyle/>
           <a:p>
-            <a:pPr marL="0" indent="0" algn="ctr">
+            <a:pPr algn="ctr" indent="0" marL="0">
               <a:buNone/>
             </a:pPr>
             <a:r>
@@ -8872,7 +9157,7 @@
           <a:bodyPr wrap="square" rtlCol="0" anchor="ctr"/>
           <a:lstStyle/>
           <a:p>
-            <a:pPr marL="0" indent="0">
+            <a:pPr indent="0" marL="0">
               <a:buNone/>
             </a:pPr>
             <a:r>
@@ -8911,7 +9196,7 @@
           <a:bodyPr wrap="square" rtlCol="0" anchor="ctr"/>
           <a:lstStyle/>
           <a:p>
-            <a:pPr marL="0" indent="0">
+            <a:pPr indent="0" marL="0">
               <a:lnSpc>
                 <a:spcPts val="1600"/>
               </a:lnSpc>
@@ -8948,7 +9233,6 @@
         <a:solidFill>
           <a:srgbClr val="F8FAFC"/>
         </a:solidFill>
-        <a:effectLst/>
       </p:bgPr>
     </p:bg>
     <p:spTree>
@@ -9013,7 +9297,7 @@
           <a:bodyPr wrap="square" rtlCol="0" anchor="ctr"/>
           <a:lstStyle/>
           <a:p>
-            <a:pPr marL="0" indent="0" algn="ctr">
+            <a:pPr algn="ctr" indent="0" marL="0">
               <a:buNone/>
             </a:pPr>
             <a:r>
@@ -9052,7 +9336,7 @@
           <a:bodyPr wrap="square" rtlCol="0" anchor="t"/>
           <a:lstStyle/>
           <a:p>
-            <a:pPr marL="0" indent="0">
+            <a:pPr indent="0" marL="0">
               <a:buNone/>
             </a:pPr>
             <a:r>
@@ -9111,7 +9395,7 @@
           <a:bodyPr wrap="square" rtlCol="0" anchor="ctr"/>
           <a:lstStyle/>
           <a:p>
-            <a:pPr marL="0" indent="0">
+            <a:pPr indent="0" marL="0">
               <a:buNone/>
             </a:pPr>
             <a:r>
@@ -9177,7 +9461,7 @@
           <a:bodyPr wrap="square" rtlCol="0" anchor="ctr"/>
           <a:lstStyle/>
           <a:p>
-            <a:pPr marL="0" indent="0">
+            <a:pPr indent="0" marL="0">
               <a:buNone/>
             </a:pPr>
             <a:r>
@@ -9216,7 +9500,7 @@
           <a:bodyPr wrap="square" rtlCol="0" anchor="ctr"/>
           <a:lstStyle/>
           <a:p>
-            <a:pPr marL="0" indent="0">
+            <a:pPr indent="0" marL="0">
               <a:buNone/>
             </a:pPr>
             <a:r>
@@ -9255,7 +9539,7 @@
           <a:bodyPr wrap="square" rtlCol="0" anchor="ctr"/>
           <a:lstStyle/>
           <a:p>
-            <a:pPr marL="0" indent="0">
+            <a:pPr indent="0" marL="0">
               <a:lnSpc>
                 <a:spcPts val="1600"/>
               </a:lnSpc>
@@ -9324,7 +9608,7 @@
           <a:bodyPr wrap="square" rtlCol="0" anchor="ctr"/>
           <a:lstStyle/>
           <a:p>
-            <a:pPr marL="0" indent="0">
+            <a:pPr indent="0" marL="0">
               <a:buNone/>
             </a:pPr>
             <a:r>
@@ -9363,7 +9647,7 @@
           <a:bodyPr wrap="square" rtlCol="0" anchor="ctr"/>
           <a:lstStyle/>
           <a:p>
-            <a:pPr marL="0" indent="0">
+            <a:pPr indent="0" marL="0">
               <a:buNone/>
             </a:pPr>
             <a:r>
@@ -9402,7 +9686,7 @@
           <a:bodyPr wrap="square" rtlCol="0" anchor="ctr"/>
           <a:lstStyle/>
           <a:p>
-            <a:pPr marL="0" indent="0">
+            <a:pPr indent="0" marL="0">
               <a:lnSpc>
                 <a:spcPts val="1600"/>
               </a:lnSpc>
@@ -9471,7 +9755,7 @@
           <a:bodyPr wrap="square" rtlCol="0" anchor="ctr"/>
           <a:lstStyle/>
           <a:p>
-            <a:pPr marL="0" indent="0">
+            <a:pPr indent="0" marL="0">
               <a:buNone/>
             </a:pPr>
             <a:r>
@@ -9510,7 +9794,7 @@
           <a:bodyPr wrap="square" rtlCol="0" anchor="ctr"/>
           <a:lstStyle/>
           <a:p>
-            <a:pPr marL="0" indent="0">
+            <a:pPr indent="0" marL="0">
               <a:buNone/>
             </a:pPr>
             <a:r>
@@ -9549,7 +9833,7 @@
           <a:bodyPr wrap="square" rtlCol="0" anchor="ctr"/>
           <a:lstStyle/>
           <a:p>
-            <a:pPr marL="0" indent="0">
+            <a:pPr indent="0" marL="0">
               <a:lnSpc>
                 <a:spcPts val="1600"/>
               </a:lnSpc>
@@ -9613,7 +9897,7 @@
           <a:bodyPr wrap="square" rtlCol="0" anchor="ctr"/>
           <a:lstStyle/>
           <a:p>
-            <a:pPr marL="0" indent="0">
+            <a:pPr indent="0" marL="0">
               <a:buNone/>
             </a:pPr>
             <a:r>
@@ -9652,7 +9936,7 @@
           <a:bodyPr wrap="square" rtlCol="0" anchor="ctr"/>
           <a:lstStyle/>
           <a:p>
-            <a:pPr marL="0" indent="0">
+            <a:pPr indent="0" marL="0">
               <a:lnSpc>
                 <a:spcPts val="1800"/>
               </a:lnSpc>
@@ -9689,7 +9973,6 @@
         <a:solidFill>
           <a:srgbClr val="F8FAFC"/>
         </a:solidFill>
-        <a:effectLst/>
       </p:bgPr>
     </p:bg>
     <p:spTree>
@@ -9754,7 +10037,7 @@
           <a:bodyPr wrap="square" rtlCol="0" anchor="ctr"/>
           <a:lstStyle/>
           <a:p>
-            <a:pPr marL="0" indent="0" algn="ctr">
+            <a:pPr algn="ctr" indent="0" marL="0">
               <a:buNone/>
             </a:pPr>
             <a:r>
@@ -9793,7 +10076,7 @@
           <a:bodyPr wrap="square" rtlCol="0" anchor="t"/>
           <a:lstStyle/>
           <a:p>
-            <a:pPr marL="0" indent="0">
+            <a:pPr indent="0" marL="0">
               <a:buNone/>
             </a:pPr>
             <a:r>
@@ -9852,7 +10135,7 @@
           <a:bodyPr wrap="square" rtlCol="0" anchor="ctr"/>
           <a:lstStyle/>
           <a:p>
-            <a:pPr marL="0" indent="0">
+            <a:pPr indent="0" marL="0">
               <a:buNone/>
             </a:pPr>
             <a:r>
@@ -9918,7 +10201,7 @@
           <a:bodyPr wrap="square" rtlCol="0" anchor="ctr"/>
           <a:lstStyle/>
           <a:p>
-            <a:pPr marL="0" indent="0">
+            <a:pPr indent="0" marL="0">
               <a:buNone/>
             </a:pPr>
             <a:r>
@@ -9957,7 +10240,7 @@
           <a:bodyPr wrap="square" rtlCol="0" anchor="ctr"/>
           <a:lstStyle/>
           <a:p>
-            <a:pPr marL="0" indent="0">
+            <a:pPr indent="0" marL="0">
               <a:buNone/>
             </a:pPr>
             <a:r>
@@ -9996,7 +10279,7 @@
           <a:bodyPr wrap="square" rtlCol="0" anchor="ctr"/>
           <a:lstStyle/>
           <a:p>
-            <a:pPr marL="0" indent="0">
+            <a:pPr indent="0" marL="0">
               <a:lnSpc>
                 <a:spcPts val="1600"/>
               </a:lnSpc>
@@ -10065,7 +10348,7 @@
           <a:bodyPr wrap="square" rtlCol="0" anchor="ctr"/>
           <a:lstStyle/>
           <a:p>
-            <a:pPr marL="0" indent="0">
+            <a:pPr indent="0" marL="0">
               <a:buNone/>
             </a:pPr>
             <a:r>
@@ -10104,7 +10387,7 @@
           <a:bodyPr wrap="square" rtlCol="0" anchor="ctr"/>
           <a:lstStyle/>
           <a:p>
-            <a:pPr marL="0" indent="0">
+            <a:pPr indent="0" marL="0">
               <a:buNone/>
             </a:pPr>
             <a:r>
@@ -10143,7 +10426,7 @@
           <a:bodyPr wrap="square" rtlCol="0" anchor="ctr"/>
           <a:lstStyle/>
           <a:p>
-            <a:pPr marL="0" indent="0">
+            <a:pPr indent="0" marL="0">
               <a:lnSpc>
                 <a:spcPts val="1600"/>
               </a:lnSpc>
@@ -10212,7 +10495,7 @@
           <a:bodyPr wrap="square" rtlCol="0" anchor="ctr"/>
           <a:lstStyle/>
           <a:p>
-            <a:pPr marL="0" indent="0">
+            <a:pPr indent="0" marL="0">
               <a:buNone/>
             </a:pPr>
             <a:r>
@@ -10251,7 +10534,7 @@
           <a:bodyPr wrap="square" rtlCol="0" anchor="ctr"/>
           <a:lstStyle/>
           <a:p>
-            <a:pPr marL="0" indent="0">
+            <a:pPr indent="0" marL="0">
               <a:buNone/>
             </a:pPr>
             <a:r>
@@ -10290,7 +10573,7 @@
           <a:bodyPr wrap="square" rtlCol="0" anchor="ctr"/>
           <a:lstStyle/>
           <a:p>
-            <a:pPr marL="0" indent="0">
+            <a:pPr indent="0" marL="0">
               <a:lnSpc>
                 <a:spcPts val="1600"/>
               </a:lnSpc>
@@ -10359,7 +10642,7 @@
           <a:bodyPr wrap="square" rtlCol="0" anchor="ctr"/>
           <a:lstStyle/>
           <a:p>
-            <a:pPr marL="0" indent="0">
+            <a:pPr indent="0" marL="0">
               <a:buNone/>
             </a:pPr>
             <a:r>
@@ -10398,7 +10681,7 @@
           <a:bodyPr wrap="square" rtlCol="0" anchor="ctr"/>
           <a:lstStyle/>
           <a:p>
-            <a:pPr marL="0" indent="0">
+            <a:pPr indent="0" marL="0">
               <a:buNone/>
             </a:pPr>
             <a:r>
@@ -10437,7 +10720,7 @@
           <a:bodyPr wrap="square" rtlCol="0" anchor="ctr"/>
           <a:lstStyle/>
           <a:p>
-            <a:pPr marL="0" indent="0">
+            <a:pPr indent="0" marL="0">
               <a:lnSpc>
                 <a:spcPts val="1600"/>
               </a:lnSpc>
@@ -10759,299 +11042,4 @@
     </a:ext>
   </a:extLst>
 </a:theme>
-</file>
-
-<file path=ppt/theme/theme2.xml><?xml version="1.0" encoding="utf-8"?>
-<a:theme xmlns:a="http://schemas.openxmlformats.org/drawingml/2006/main" name="Office Theme">
-  <a:themeElements>
-    <a:clrScheme name="Office">
-      <a:dk1>
-        <a:sysClr val="windowText" lastClr="000000"/>
-      </a:dk1>
-      <a:lt1>
-        <a:sysClr val="window" lastClr="FFFFFF"/>
-      </a:lt1>
-      <a:dk2>
-        <a:srgbClr val="44546A"/>
-      </a:dk2>
-      <a:lt2>
-        <a:srgbClr val="E7E6E6"/>
-      </a:lt2>
-      <a:accent1>
-        <a:srgbClr val="4472C4"/>
-      </a:accent1>
-      <a:accent2>
-        <a:srgbClr val="ED7D31"/>
-      </a:accent2>
-      <a:accent3>
-        <a:srgbClr val="A5A5A5"/>
-      </a:accent3>
-      <a:accent4>
-        <a:srgbClr val="FFC000"/>
-      </a:accent4>
-      <a:accent5>
-        <a:srgbClr val="5B9BD5"/>
-      </a:accent5>
-      <a:accent6>
-        <a:srgbClr val="70AD47"/>
-      </a:accent6>
-      <a:hlink>
-        <a:srgbClr val="0563C1"/>
-      </a:hlink>
-      <a:folHlink>
-        <a:srgbClr val="954F72"/>
-      </a:folHlink>
-    </a:clrScheme>
-    <a:fontScheme name="Office">
-      <a:majorFont>
-        <a:latin typeface="Calibri Light" panose="020F0302020204030204"/>
-        <a:ea typeface=""/>
-        <a:cs typeface=""/>
-        <a:font script="Jpan" typeface="游ゴシック Light"/>
-        <a:font script="Hang" typeface="맑은 고딕"/>
-        <a:font script="Hans" typeface="等线 Light"/>
-        <a:font script="Hant" typeface="新細明體"/>
-        <a:font script="Arab" typeface="Times New Roman"/>
-        <a:font script="Hebr" typeface="Times New Roman"/>
-        <a:font script="Thai" typeface="Angsana New"/>
-        <a:font script="Ethi" typeface="Nyala"/>
-        <a:font script="Beng" typeface="Vrinda"/>
-        <a:font script="Gujr" typeface="Shruti"/>
-        <a:font script="Khmr" typeface="MoolBoran"/>
-        <a:font script="Knda" typeface="Tunga"/>
-        <a:font script="Guru" typeface="Raavi"/>
-        <a:font script="Cans" typeface="Euphemia"/>
-        <a:font script="Cher" typeface="Plantagenet Cherokee"/>
-        <a:font script="Yiii" typeface="Microsoft Yi Baiti"/>
-        <a:font script="Tibt" typeface="Microsoft Himalaya"/>
-        <a:font script="Thaa" typeface="MV Boli"/>
-        <a:font script="Deva" typeface="Mangal"/>
-        <a:font script="Telu" typeface="Gautami"/>
-        <a:font script="Taml" typeface="Latha"/>
-        <a:font script="Syrc" typeface="Estrangelo Edessa"/>
-        <a:font script="Orya" typeface="Kalinga"/>
-        <a:font script="Mlym" typeface="Kartika"/>
-        <a:font script="Laoo" typeface="DokChampa"/>
-        <a:font script="Sinh" typeface="Iskoola Pota"/>
-        <a:font script="Mong" typeface="Mongolian Baiti"/>
-        <a:font script="Viet" typeface="Times New Roman"/>
-        <a:font script="Uigh" typeface="Microsoft Uighur"/>
-        <a:font script="Geor" typeface="Sylfaen"/>
-        <a:font script="Armn" typeface="Arial"/>
-        <a:font script="Bugi" typeface="Leelawadee UI"/>
-        <a:font script="Bopo" typeface="Microsoft JhengHei"/>
-        <a:font script="Java" typeface="Javanese Text"/>
-        <a:font script="Lisu" typeface="Segoe UI"/>
-        <a:font script="Mymr" typeface="Myanmar Text"/>
-        <a:font script="Nkoo" typeface="Ebrima"/>
-        <a:font script="Olck" typeface="Nirmala UI"/>
-        <a:font script="Osma" typeface="Ebrima"/>
-        <a:font script="Phag" typeface="Phagspa"/>
-        <a:font script="Syrn" typeface="Estrangelo Edessa"/>
-        <a:font script="Syrj" typeface="Estrangelo Edessa"/>
-        <a:font script="Syre" typeface="Estrangelo Edessa"/>
-        <a:font script="Sora" typeface="Nirmala UI"/>
-        <a:font script="Tale" typeface="Microsoft Tai Le"/>
-        <a:font script="Talu" typeface="Microsoft New Tai Lue"/>
-        <a:font script="Tfng" typeface="Ebrima"/>
-      </a:majorFont>
-      <a:minorFont>
-        <a:latin typeface="Calibri" panose="020F0502020204030204"/>
-        <a:ea typeface=""/>
-        <a:cs typeface=""/>
-        <a:font script="Jpan" typeface="游ゴシック"/>
-        <a:font script="Hang" typeface="맑은 고딕"/>
-        <a:font script="Hans" typeface="等线"/>
-        <a:font script="Hant" typeface="新細明體"/>
-        <a:font script="Arab" typeface="Arial"/>
-        <a:font script="Hebr" typeface="Arial"/>
-        <a:font script="Thai" typeface="Cordia New"/>
-        <a:font script="Ethi" typeface="Nyala"/>
-        <a:font script="Beng" typeface="Vrinda"/>
-        <a:font script="Gujr" typeface="Shruti"/>
-        <a:font script="Khmr" typeface="DaunPenh"/>
-        <a:font script="Knda" typeface="Tunga"/>
-        <a:font script="Guru" typeface="Raavi"/>
-        <a:font script="Cans" typeface="Euphemia"/>
-        <a:font script="Cher" typeface="Plantagenet Cherokee"/>
-        <a:font script="Yiii" typeface="Microsoft Yi Baiti"/>
-        <a:font script="Tibt" typeface="Microsoft Himalaya"/>
-        <a:font script="Thaa" typeface="MV Boli"/>
-        <a:font script="Deva" typeface="Mangal"/>
-        <a:font script="Telu" typeface="Gautami"/>
-        <a:font script="Taml" typeface="Latha"/>
-        <a:font script="Syrc" typeface="Estrangelo Edessa"/>
-        <a:font script="Orya" typeface="Kalinga"/>
-        <a:font script="Mlym" typeface="Kartika"/>
-        <a:font script="Laoo" typeface="DokChampa"/>
-        <a:font script="Sinh" typeface="Iskoola Pota"/>
-        <a:font script="Mong" typeface="Mongolian Baiti"/>
-        <a:font script="Viet" typeface="Arial"/>
-        <a:font script="Uigh" typeface="Microsoft Uighur"/>
-        <a:font script="Geor" typeface="Sylfaen"/>
-        <a:font script="Armn" typeface="Arial"/>
-        <a:font script="Bugi" typeface="Leelawadee UI"/>
-        <a:font script="Bopo" typeface="Microsoft JhengHei"/>
-        <a:font script="Java" typeface="Javanese Text"/>
-        <a:font script="Lisu" typeface="Segoe UI"/>
-        <a:font script="Mymr" typeface="Myanmar Text"/>
-        <a:font script="Nkoo" typeface="Ebrima"/>
-        <a:font script="Olck" typeface="Nirmala UI"/>
-        <a:font script="Osma" typeface="Ebrima"/>
-        <a:font script="Phag" typeface="Phagspa"/>
-        <a:font script="Syrn" typeface="Estrangelo Edessa"/>
-        <a:font script="Syrj" typeface="Estrangelo Edessa"/>
-        <a:font script="Syre" typeface="Estrangelo Edessa"/>
-        <a:font script="Sora" typeface="Nirmala UI"/>
-        <a:font script="Tale" typeface="Microsoft Tai Le"/>
-        <a:font script="Talu" typeface="Microsoft New Tai Lue"/>
-        <a:font script="Tfng" typeface="Ebrima"/>
-      </a:minorFont>
-    </a:fontScheme>
-    <a:fmtScheme name="Office">
-      <a:fillStyleLst>
-        <a:solidFill>
-          <a:schemeClr val="phClr"/>
-        </a:solidFill>
-        <a:gradFill rotWithShape="1">
-          <a:gsLst>
-            <a:gs pos="0">
-              <a:schemeClr val="phClr">
-                <a:lumMod val="110000"/>
-                <a:satMod val="105000"/>
-                <a:tint val="67000"/>
-              </a:schemeClr>
-            </a:gs>
-            <a:gs pos="50000">
-              <a:schemeClr val="phClr">
-                <a:lumMod val="105000"/>
-                <a:satMod val="103000"/>
-                <a:tint val="73000"/>
-              </a:schemeClr>
-            </a:gs>
-            <a:gs pos="100000">
-              <a:schemeClr val="phClr">
-                <a:lumMod val="105000"/>
-                <a:satMod val="109000"/>
-                <a:tint val="81000"/>
-              </a:schemeClr>
-            </a:gs>
-          </a:gsLst>
-          <a:lin ang="5400000" scaled="0"/>
-        </a:gradFill>
-        <a:gradFill rotWithShape="1">
-          <a:gsLst>
-            <a:gs pos="0">
-              <a:schemeClr val="phClr">
-                <a:satMod val="103000"/>
-                <a:lumMod val="102000"/>
-                <a:tint val="94000"/>
-              </a:schemeClr>
-            </a:gs>
-            <a:gs pos="50000">
-              <a:schemeClr val="phClr">
-                <a:satMod val="110000"/>
-                <a:lumMod val="100000"/>
-                <a:shade val="100000"/>
-              </a:schemeClr>
-            </a:gs>
-            <a:gs pos="100000">
-              <a:schemeClr val="phClr">
-                <a:lumMod val="99000"/>
-                <a:satMod val="120000"/>
-                <a:shade val="78000"/>
-              </a:schemeClr>
-            </a:gs>
-          </a:gsLst>
-          <a:lin ang="5400000" scaled="0"/>
-        </a:gradFill>
-      </a:fillStyleLst>
-      <a:lnStyleLst>
-        <a:ln w="6350" cap="flat" cmpd="sng" algn="ctr">
-          <a:solidFill>
-            <a:schemeClr val="phClr"/>
-          </a:solidFill>
-          <a:prstDash val="solid"/>
-          <a:miter lim="800000"/>
-        </a:ln>
-        <a:ln w="12700" cap="flat" cmpd="sng" algn="ctr">
-          <a:solidFill>
-            <a:schemeClr val="phClr"/>
-          </a:solidFill>
-          <a:prstDash val="solid"/>
-          <a:miter lim="800000"/>
-        </a:ln>
-        <a:ln w="19050" cap="flat" cmpd="sng" algn="ctr">
-          <a:solidFill>
-            <a:schemeClr val="phClr"/>
-          </a:solidFill>
-          <a:prstDash val="solid"/>
-          <a:miter lim="800000"/>
-        </a:ln>
-      </a:lnStyleLst>
-      <a:effectStyleLst>
-        <a:effectStyle>
-          <a:effectLst/>
-        </a:effectStyle>
-        <a:effectStyle>
-          <a:effectLst/>
-        </a:effectStyle>
-        <a:effectStyle>
-          <a:effectLst>
-            <a:outerShdw blurRad="57150" dist="19050" dir="5400000" algn="ctr" rotWithShape="0">
-              <a:srgbClr val="000000">
-                <a:alpha val="63000"/>
-              </a:srgbClr>
-            </a:outerShdw>
-          </a:effectLst>
-        </a:effectStyle>
-      </a:effectStyleLst>
-      <a:bgFillStyleLst>
-        <a:solidFill>
-          <a:schemeClr val="phClr"/>
-        </a:solidFill>
-        <a:solidFill>
-          <a:schemeClr val="phClr">
-            <a:tint val="95000"/>
-            <a:satMod val="170000"/>
-          </a:schemeClr>
-        </a:solidFill>
-        <a:gradFill rotWithShape="1">
-          <a:gsLst>
-            <a:gs pos="0">
-              <a:schemeClr val="phClr">
-                <a:tint val="93000"/>
-                <a:satMod val="150000"/>
-                <a:shade val="98000"/>
-                <a:lumMod val="102000"/>
-              </a:schemeClr>
-            </a:gs>
-            <a:gs pos="50000">
-              <a:schemeClr val="phClr">
-                <a:tint val="98000"/>
-                <a:satMod val="130000"/>
-                <a:shade val="90000"/>
-                <a:lumMod val="103000"/>
-              </a:schemeClr>
-            </a:gs>
-            <a:gs pos="100000">
-              <a:schemeClr val="phClr">
-                <a:shade val="63000"/>
-                <a:satMod val="120000"/>
-              </a:schemeClr>
-            </a:gs>
-          </a:gsLst>
-          <a:lin ang="5400000" scaled="0"/>
-        </a:gradFill>
-      </a:bgFillStyleLst>
-    </a:fmtScheme>
-  </a:themeElements>
-  <a:objectDefaults/>
-  <a:extraClrSchemeLst/>
-  <a:extLst>
-    <a:ext uri="{05A4C25C-085E-4340-85A3-A5531E510DB2}">
-      <thm15:themeFamily xmlns:thm15="http://schemas.microsoft.com/office/thememl/2012/main" name="Office Theme" id="{62F939B6-93AF-4DB8-9C6B-D6C7DFDC589F}" vid="{4A3C46E8-61CC-4603-A589-7422A47A8E4A}"/>
-    </a:ext>
-  </a:extLst>
-</a:theme>
 </file>
</xml_diff>